<commit_message>
fix: tighten Week 2 slide layouts and clean text artifacts (en+zh)
The generated decks kept card containers at fixed heights while content
was laid out with absolute coordinates, leaving 2-6 cm dead zones inside
cards whenever the text ran short. Systematic pass over both decks:

- P6/P17/P21 (three-card layouts): example/code blocks pulled up to sit
  under the description, cards shrunk to fit, lower sections raised
- P19: numbered step cards compacted and all six titles aligned
  (Audit sat 0.4 cm higher than its siblings)
- P24: bottom info boxes shrunk to their content
- P4/P11/P25/P26: vertical rebalancing only
- P28 left untouched: its code block overflows its container by design,
  shrinking would cut it (guard caught this)
- text: removed a leftover duplicated sentence on slide 6 (both decks),
  fixed missing spaces after colons in 4 runs
- verified by rendering every touched page to PNG before/after
</commit_message>
<xml_diff>
--- a/lectures/week-02/lecture-en.pptx
+++ b/lectures/week-02/lecture-en.pptx
@@ -2593,7 +2593,7 @@
         </p:nvSpPr>
         <p:spPr>
           <a:xfrm rot="0" flipH="0" flipV="0">
-            <a:off x="800100" y="1085850"/>
+            <a:off x="800100" y="1586512"/>
             <a:ext cx="5334000" cy="3114675"/>
           </a:xfrm>
           <a:prstGeom prst="roundRect">
@@ -2619,7 +2619,7 @@
         </p:nvSpPr>
         <p:spPr>
           <a:xfrm rot="0" flipH="0" flipV="0">
-            <a:off x="1009650" y="1238250"/>
+            <a:off x="1009650" y="1738912"/>
             <a:ext cx="4914900" cy="161925"/>
           </a:xfrm>
           <a:prstGeom prst="rect"/>
@@ -2654,7 +2654,7 @@
         </p:nvSpPr>
         <p:spPr>
           <a:xfrm rot="0" flipH="0" flipV="0">
-            <a:off x="1009650" y="1457325"/>
+            <a:off x="1009650" y="1957987"/>
             <a:ext cx="4914900" cy="1238250"/>
           </a:xfrm>
           <a:prstGeom prst="rect"/>
@@ -2743,7 +2743,7 @@
         </p:nvSpPr>
         <p:spPr>
           <a:xfrm rot="0" flipH="0" flipV="0">
-            <a:off x="1009650" y="2790825"/>
+            <a:off x="1009650" y="3291487"/>
             <a:ext cx="4914900" cy="9525"/>
           </a:xfrm>
           <a:prstGeom prst="rect">
@@ -2769,7 +2769,7 @@
         </p:nvSpPr>
         <p:spPr>
           <a:xfrm rot="0" flipH="0" flipV="0">
-            <a:off x="1009650" y="2895600"/>
+            <a:off x="1009650" y="3396262"/>
             <a:ext cx="4914900" cy="161925"/>
           </a:xfrm>
           <a:prstGeom prst="rect"/>
@@ -2804,7 +2804,7 @@
         </p:nvSpPr>
         <p:spPr>
           <a:xfrm rot="0" flipH="0" flipV="0">
-            <a:off x="1009650" y="3114675"/>
+            <a:off x="1009650" y="3615337"/>
             <a:ext cx="4914900" cy="933450"/>
           </a:xfrm>
           <a:prstGeom prst="rect"/>
@@ -2875,7 +2875,7 @@
         </p:nvSpPr>
         <p:spPr>
           <a:xfrm rot="0" flipH="0" flipV="0">
-            <a:off x="800100" y="4314825"/>
+            <a:off x="800100" y="4815487"/>
             <a:ext cx="5334000" cy="762000"/>
           </a:xfrm>
           <a:prstGeom prst="roundRect">
@@ -2906,7 +2906,7 @@
         </p:nvSpPr>
         <p:spPr>
           <a:xfrm rot="0" flipH="0" flipV="0">
-            <a:off x="971550" y="4429125"/>
+            <a:off x="971550" y="4929787"/>
             <a:ext cx="4991100" cy="533400"/>
           </a:xfrm>
           <a:prstGeom prst="rect"/>
@@ -2929,7 +2929,7 @@
                 <a:latin typeface="Inter"/>
                 <a:ea typeface="Inter"/>
               </a:rPr>
-              <a:t>Slicing returns a view, not a copy:</a:t>
+              <a:t>Slicing returns a view, not a copy: </a:t>
             </a:r>
             <a:r>
               <a:rPr lang="en-US" sz="1088">
@@ -2983,7 +2983,7 @@
         </p:nvSpPr>
         <p:spPr>
           <a:xfrm rot="0" flipH="0" flipV="0">
-            <a:off x="6419850" y="2114550"/>
+            <a:off x="6419850" y="2615212"/>
             <a:ext cx="4972050" cy="228600"/>
           </a:xfrm>
           <a:prstGeom prst="rect"/>
@@ -3018,7 +3018,7 @@
         </p:nvSpPr>
         <p:spPr>
           <a:xfrm rot="0" flipH="0" flipV="0">
-            <a:off x="6419850" y="2457450"/>
+            <a:off x="6419850" y="2958112"/>
             <a:ext cx="4972050" cy="552450"/>
           </a:xfrm>
           <a:prstGeom prst="rect"/>
@@ -3075,7 +3075,7 @@
         </p:nvSpPr>
         <p:spPr>
           <a:xfrm rot="0" flipH="0" flipV="0">
-            <a:off x="6419850" y="3124200"/>
+            <a:off x="6419850" y="3624862"/>
             <a:ext cx="4972050" cy="1143000"/>
           </a:xfrm>
           <a:prstGeom prst="roundRect">
@@ -3106,7 +3106,7 @@
         </p:nvSpPr>
         <p:spPr>
           <a:xfrm rot="0" flipH="0" flipV="0">
-            <a:off x="6610350" y="3352800"/>
+            <a:off x="6610350" y="3853462"/>
             <a:ext cx="1809750" cy="180975"/>
           </a:xfrm>
           <a:prstGeom prst="rect"/>
@@ -3155,7 +3155,7 @@
         </p:blipFill>
         <p:spPr>
           <a:xfrm rot="0" flipH="0" flipV="0">
-            <a:off x="8534400" y="3352800"/>
+            <a:off x="8534400" y="3853462"/>
             <a:ext cx="171450" cy="171450"/>
           </a:xfrm>
           <a:prstGeom prst="rect">
@@ -3172,7 +3172,7 @@
         </p:nvSpPr>
         <p:spPr>
           <a:xfrm rot="0" flipH="0" flipV="0">
-            <a:off x="8820150" y="3276600"/>
+            <a:off x="8820150" y="3777262"/>
             <a:ext cx="2381250" cy="323850"/>
           </a:xfrm>
           <a:prstGeom prst="rect"/>
@@ -3209,7 +3209,7 @@
         </p:nvSpPr>
         <p:spPr>
           <a:xfrm rot="0" flipH="0" flipV="0">
-            <a:off x="6610350" y="3676650"/>
+            <a:off x="6610350" y="4177312"/>
             <a:ext cx="1809750" cy="180975"/>
           </a:xfrm>
           <a:prstGeom prst="rect"/>
@@ -3258,7 +3258,7 @@
         </p:blipFill>
         <p:spPr>
           <a:xfrm rot="0" flipH="0" flipV="0">
-            <a:off x="8534400" y="3686175"/>
+            <a:off x="8534400" y="4186837"/>
             <a:ext cx="171450" cy="171450"/>
           </a:xfrm>
           <a:prstGeom prst="rect">
@@ -3275,7 +3275,7 @@
         </p:nvSpPr>
         <p:spPr>
           <a:xfrm rot="0" flipH="0" flipV="0">
-            <a:off x="8820150" y="3686175"/>
+            <a:off x="8820150" y="4186837"/>
             <a:ext cx="2381250" cy="161925"/>
           </a:xfrm>
           <a:prstGeom prst="rect"/>
@@ -3310,7 +3310,7 @@
         </p:nvSpPr>
         <p:spPr>
           <a:xfrm rot="0" flipH="0" flipV="0">
-            <a:off x="6610350" y="3933825"/>
+            <a:off x="6610350" y="4434487"/>
             <a:ext cx="1809750" cy="180975"/>
           </a:xfrm>
           <a:prstGeom prst="rect"/>
@@ -3359,7 +3359,7 @@
         </p:blipFill>
         <p:spPr>
           <a:xfrm rot="0" flipH="0" flipV="0">
-            <a:off x="8534400" y="3943350"/>
+            <a:off x="8534400" y="4444012"/>
             <a:ext cx="171450" cy="171450"/>
           </a:xfrm>
           <a:prstGeom prst="rect">
@@ -3376,7 +3376,7 @@
         </p:nvSpPr>
         <p:spPr>
           <a:xfrm rot="0" flipH="0" flipV="0">
-            <a:off x="8820150" y="3943350"/>
+            <a:off x="8820150" y="4444012"/>
             <a:ext cx="2381250" cy="161925"/>
           </a:xfrm>
           <a:prstGeom prst="rect"/>
@@ -3411,7 +3411,7 @@
         </p:nvSpPr>
         <p:spPr>
           <a:xfrm rot="0" flipH="0" flipV="0">
-            <a:off x="6419850" y="4381500"/>
+            <a:off x="6419850" y="4882162"/>
             <a:ext cx="5010150" cy="552450"/>
           </a:xfrm>
           <a:custGeom>
@@ -3451,7 +3451,7 @@
         </p:nvSpPr>
         <p:spPr>
           <a:xfrm rot="0" flipH="0" flipV="0">
-            <a:off x="6591300" y="4381500"/>
+            <a:off x="6591300" y="4882162"/>
             <a:ext cx="4800600" cy="552450"/>
           </a:xfrm>
           <a:prstGeom prst="rect"/>
@@ -10960,8 +10960,8 @@
         </p:nvSpPr>
         <p:spPr>
           <a:xfrm rot="0" flipH="0" flipV="0">
-            <a:off x="800100" y="1123950"/>
-            <a:ext cx="2009775" cy="3924300"/>
+            <a:off x="800100" y="1883813"/>
+            <a:ext cx="2009775" cy="2481974"/>
           </a:xfrm>
           <a:prstGeom prst="roundRect">
             <a:avLst>
@@ -10986,8 +10986,8 @@
         </p:nvSpPr>
         <p:spPr>
           <a:xfrm rot="0" flipH="0" flipV="0">
-            <a:off x="800100" y="1123950"/>
-            <a:ext cx="2009775" cy="3924300"/>
+            <a:off x="800100" y="1883813"/>
+            <a:ext cx="2009775" cy="2481974"/>
           </a:xfrm>
           <a:custGeom>
             <a:pathLst>
@@ -11043,7 +11043,7 @@
         </p:nvSpPr>
         <p:spPr>
           <a:xfrm rot="0" flipH="0" flipV="0">
-            <a:off x="933450" y="1257300"/>
+            <a:off x="933450" y="2017163"/>
             <a:ext cx="285750" cy="285750"/>
           </a:xfrm>
           <a:prstGeom prst="roundRect">
@@ -11069,7 +11069,7 @@
         </p:nvSpPr>
         <p:spPr>
           <a:xfrm rot="0" flipH="0" flipV="0">
-            <a:off x="1038225" y="1314450"/>
+            <a:off x="1038225" y="2074313"/>
             <a:ext cx="85725" cy="171450"/>
           </a:xfrm>
           <a:prstGeom prst="rect"/>
@@ -11104,7 +11104,7 @@
         </p:nvSpPr>
         <p:spPr>
           <a:xfrm rot="0" flipH="0" flipV="0">
-            <a:off x="933450" y="1619250"/>
+            <a:off x="933450" y="2379113"/>
             <a:ext cx="1743075" cy="209550"/>
           </a:xfrm>
           <a:prstGeom prst="rect"/>
@@ -11139,7 +11139,7 @@
         </p:nvSpPr>
         <p:spPr>
           <a:xfrm rot="0" flipH="0" flipV="0">
-            <a:off x="933450" y="1857375"/>
+            <a:off x="933450" y="2617238"/>
             <a:ext cx="1743075" cy="142875"/>
           </a:xfrm>
           <a:prstGeom prst="rect"/>
@@ -11174,7 +11174,7 @@
         </p:nvSpPr>
         <p:spPr>
           <a:xfrm rot="0" flipH="0" flipV="0">
-            <a:off x="933450" y="4029075"/>
+            <a:off x="933450" y="3338062"/>
             <a:ext cx="1743075" cy="847725"/>
           </a:xfrm>
           <a:prstGeom prst="roundRect">
@@ -11200,7 +11200,7 @@
         </p:nvSpPr>
         <p:spPr>
           <a:xfrm rot="0" flipH="0" flipV="0">
-            <a:off x="1038225" y="4114800"/>
+            <a:off x="1038225" y="3423787"/>
             <a:ext cx="1533525" cy="676275"/>
           </a:xfrm>
           <a:prstGeom prst="rect"/>
@@ -11237,8 +11237,8 @@
         </p:nvSpPr>
         <p:spPr>
           <a:xfrm rot="0" flipH="0" flipV="0">
-            <a:off x="2943225" y="1123950"/>
-            <a:ext cx="2009775" cy="3924300"/>
+            <a:off x="2943225" y="1883813"/>
+            <a:ext cx="2009775" cy="2481974"/>
           </a:xfrm>
           <a:prstGeom prst="roundRect">
             <a:avLst>
@@ -11263,8 +11263,8 @@
         </p:nvSpPr>
         <p:spPr>
           <a:xfrm rot="0" flipH="0" flipV="0">
-            <a:off x="2943225" y="1123950"/>
-            <a:ext cx="2009775" cy="3924300"/>
+            <a:off x="2943225" y="1883813"/>
+            <a:ext cx="2009775" cy="2481974"/>
           </a:xfrm>
           <a:custGeom>
             <a:pathLst>
@@ -11320,7 +11320,7 @@
         </p:nvSpPr>
         <p:spPr>
           <a:xfrm rot="0" flipH="0" flipV="0">
-            <a:off x="3076575" y="1257300"/>
+            <a:off x="3076575" y="2017163"/>
             <a:ext cx="285750" cy="285750"/>
           </a:xfrm>
           <a:prstGeom prst="roundRect">
@@ -11346,7 +11346,7 @@
         </p:nvSpPr>
         <p:spPr>
           <a:xfrm rot="0" flipH="0" flipV="0">
-            <a:off x="3181350" y="1314450"/>
+            <a:off x="3181350" y="2074313"/>
             <a:ext cx="85725" cy="171450"/>
           </a:xfrm>
           <a:prstGeom prst="rect"/>
@@ -11381,7 +11381,7 @@
         </p:nvSpPr>
         <p:spPr>
           <a:xfrm rot="0" flipH="0" flipV="0">
-            <a:off x="3076575" y="1619250"/>
+            <a:off x="3076575" y="2379113"/>
             <a:ext cx="1743075" cy="209550"/>
           </a:xfrm>
           <a:prstGeom prst="rect"/>
@@ -11416,7 +11416,7 @@
         </p:nvSpPr>
         <p:spPr>
           <a:xfrm rot="0" flipH="0" flipV="0">
-            <a:off x="3076575" y="1857375"/>
+            <a:off x="3076575" y="2617238"/>
             <a:ext cx="1743075" cy="142875"/>
           </a:xfrm>
           <a:prstGeom prst="rect"/>
@@ -11451,7 +11451,7 @@
         </p:nvSpPr>
         <p:spPr>
           <a:xfrm rot="0" flipH="0" flipV="0">
-            <a:off x="3076575" y="4029075"/>
+            <a:off x="3076575" y="3338062"/>
             <a:ext cx="1743075" cy="847725"/>
           </a:xfrm>
           <a:prstGeom prst="roundRect">
@@ -11477,7 +11477,7 @@
         </p:nvSpPr>
         <p:spPr>
           <a:xfrm rot="0" flipH="0" flipV="0">
-            <a:off x="3181350" y="4114800"/>
+            <a:off x="3181350" y="3423787"/>
             <a:ext cx="1533525" cy="676275"/>
           </a:xfrm>
           <a:prstGeom prst="rect"/>
@@ -11514,8 +11514,8 @@
         </p:nvSpPr>
         <p:spPr>
           <a:xfrm rot="0" flipH="0" flipV="0">
-            <a:off x="5086350" y="1123950"/>
-            <a:ext cx="2019300" cy="3924300"/>
+            <a:off x="5086350" y="1883813"/>
+            <a:ext cx="2019300" cy="2481974"/>
           </a:xfrm>
           <a:prstGeom prst="roundRect">
             <a:avLst>
@@ -11540,8 +11540,8 @@
         </p:nvSpPr>
         <p:spPr>
           <a:xfrm rot="0" flipH="0" flipV="0">
-            <a:off x="5086350" y="1123950"/>
-            <a:ext cx="2019300" cy="3924300"/>
+            <a:off x="5086350" y="1883813"/>
+            <a:ext cx="2019300" cy="2481974"/>
           </a:xfrm>
           <a:custGeom>
             <a:pathLst>
@@ -11597,7 +11597,7 @@
         </p:nvSpPr>
         <p:spPr>
           <a:xfrm rot="0" flipH="0" flipV="0">
-            <a:off x="5219700" y="1257300"/>
+            <a:off x="5219700" y="2017163"/>
             <a:ext cx="285750" cy="285750"/>
           </a:xfrm>
           <a:prstGeom prst="roundRect">
@@ -11623,7 +11623,7 @@
         </p:nvSpPr>
         <p:spPr>
           <a:xfrm rot="0" flipH="0" flipV="0">
-            <a:off x="5324475" y="1314450"/>
+            <a:off x="5324475" y="2074313"/>
             <a:ext cx="85725" cy="171450"/>
           </a:xfrm>
           <a:prstGeom prst="rect"/>
@@ -11658,7 +11658,7 @@
         </p:nvSpPr>
         <p:spPr>
           <a:xfrm rot="0" flipH="0" flipV="0">
-            <a:off x="5219700" y="1619250"/>
+            <a:off x="5219700" y="2379113"/>
             <a:ext cx="1752600" cy="209550"/>
           </a:xfrm>
           <a:prstGeom prst="rect"/>
@@ -11693,7 +11693,7 @@
         </p:nvSpPr>
         <p:spPr>
           <a:xfrm rot="0" flipH="0" flipV="0">
-            <a:off x="5219700" y="1857375"/>
+            <a:off x="5219700" y="2617238"/>
             <a:ext cx="1752600" cy="285750"/>
           </a:xfrm>
           <a:prstGeom prst="rect"/>
@@ -11730,7 +11730,7 @@
         </p:nvSpPr>
         <p:spPr>
           <a:xfrm rot="0" flipH="0" flipV="0">
-            <a:off x="5219700" y="4029075"/>
+            <a:off x="5219700" y="3338062"/>
             <a:ext cx="1752600" cy="847725"/>
           </a:xfrm>
           <a:prstGeom prst="roundRect">
@@ -11756,7 +11756,7 @@
         </p:nvSpPr>
         <p:spPr>
           <a:xfrm rot="0" flipH="0" flipV="0">
-            <a:off x="5324475" y="4114800"/>
+            <a:off x="5324475" y="3423787"/>
             <a:ext cx="1543050" cy="676275"/>
           </a:xfrm>
           <a:prstGeom prst="rect"/>
@@ -11793,8 +11793,8 @@
         </p:nvSpPr>
         <p:spPr>
           <a:xfrm rot="0" flipH="0" flipV="0">
-            <a:off x="7239000" y="1123950"/>
-            <a:ext cx="2009775" cy="3924300"/>
+            <a:off x="7239000" y="1883813"/>
+            <a:ext cx="2009775" cy="2481974"/>
           </a:xfrm>
           <a:prstGeom prst="roundRect">
             <a:avLst>
@@ -11819,8 +11819,8 @@
         </p:nvSpPr>
         <p:spPr>
           <a:xfrm rot="0" flipH="0" flipV="0">
-            <a:off x="7239000" y="1123950"/>
-            <a:ext cx="2009775" cy="3924300"/>
+            <a:off x="7239000" y="1883813"/>
+            <a:ext cx="2009775" cy="2481974"/>
           </a:xfrm>
           <a:custGeom>
             <a:pathLst>
@@ -11876,7 +11876,7 @@
         </p:nvSpPr>
         <p:spPr>
           <a:xfrm rot="0" flipH="0" flipV="0">
-            <a:off x="7372350" y="1257300"/>
+            <a:off x="7372350" y="2017163"/>
             <a:ext cx="285750" cy="285750"/>
           </a:xfrm>
           <a:prstGeom prst="roundRect">
@@ -11902,7 +11902,7 @@
         </p:nvSpPr>
         <p:spPr>
           <a:xfrm rot="0" flipH="0" flipV="0">
-            <a:off x="7477125" y="1314450"/>
+            <a:off x="7477125" y="2074313"/>
             <a:ext cx="85725" cy="171450"/>
           </a:xfrm>
           <a:prstGeom prst="rect"/>
@@ -11937,7 +11937,7 @@
         </p:nvSpPr>
         <p:spPr>
           <a:xfrm rot="0" flipH="0" flipV="0">
-            <a:off x="7372350" y="1619250"/>
+            <a:off x="7372350" y="2379113"/>
             <a:ext cx="1743075" cy="209550"/>
           </a:xfrm>
           <a:prstGeom prst="rect"/>
@@ -11972,7 +11972,7 @@
         </p:nvSpPr>
         <p:spPr>
           <a:xfrm rot="0" flipH="0" flipV="0">
-            <a:off x="7372350" y="1857375"/>
+            <a:off x="7372350" y="2617238"/>
             <a:ext cx="1743075" cy="142875"/>
           </a:xfrm>
           <a:prstGeom prst="rect"/>
@@ -12007,7 +12007,7 @@
         </p:nvSpPr>
         <p:spPr>
           <a:xfrm rot="0" flipH="0" flipV="0">
-            <a:off x="7372350" y="4029075"/>
+            <a:off x="7372350" y="3338062"/>
             <a:ext cx="1743075" cy="847725"/>
           </a:xfrm>
           <a:prstGeom prst="roundRect">
@@ -12033,7 +12033,7 @@
         </p:nvSpPr>
         <p:spPr>
           <a:xfrm rot="0" flipH="0" flipV="0">
-            <a:off x="7477125" y="4114800"/>
+            <a:off x="7477125" y="3423787"/>
             <a:ext cx="1533525" cy="676275"/>
           </a:xfrm>
           <a:prstGeom prst="rect"/>
@@ -12070,8 +12070,8 @@
         </p:nvSpPr>
         <p:spPr>
           <a:xfrm rot="0" flipH="0" flipV="0">
-            <a:off x="9382125" y="1123950"/>
-            <a:ext cx="2009775" cy="3924300"/>
+            <a:off x="9382125" y="1883813"/>
+            <a:ext cx="2009775" cy="2481974"/>
           </a:xfrm>
           <a:prstGeom prst="roundRect">
             <a:avLst>
@@ -12096,8 +12096,8 @@
         </p:nvSpPr>
         <p:spPr>
           <a:xfrm rot="0" flipH="0" flipV="0">
-            <a:off x="9382125" y="1123950"/>
-            <a:ext cx="2009775" cy="3924300"/>
+            <a:off x="9382125" y="1883813"/>
+            <a:ext cx="2009775" cy="2481974"/>
           </a:xfrm>
           <a:custGeom>
             <a:pathLst>
@@ -12153,7 +12153,7 @@
         </p:nvSpPr>
         <p:spPr>
           <a:xfrm rot="0" flipH="0" flipV="0">
-            <a:off x="9515475" y="1257300"/>
+            <a:off x="9515475" y="2017163"/>
             <a:ext cx="285750" cy="285750"/>
           </a:xfrm>
           <a:prstGeom prst="roundRect">
@@ -12179,7 +12179,7 @@
         </p:nvSpPr>
         <p:spPr>
           <a:xfrm rot="0" flipH="0" flipV="0">
-            <a:off x="9620250" y="1314450"/>
+            <a:off x="9620250" y="2074313"/>
             <a:ext cx="85725" cy="171450"/>
           </a:xfrm>
           <a:prstGeom prst="rect"/>
@@ -12214,7 +12214,7 @@
         </p:nvSpPr>
         <p:spPr>
           <a:xfrm rot="0" flipH="0" flipV="0">
-            <a:off x="9515475" y="1619250"/>
+            <a:off x="9515475" y="2379113"/>
             <a:ext cx="1743075" cy="209550"/>
           </a:xfrm>
           <a:prstGeom prst="rect"/>
@@ -12249,7 +12249,7 @@
         </p:nvSpPr>
         <p:spPr>
           <a:xfrm rot="0" flipH="0" flipV="0">
-            <a:off x="9515475" y="1857375"/>
+            <a:off x="9515475" y="2617238"/>
             <a:ext cx="1743075" cy="142875"/>
           </a:xfrm>
           <a:prstGeom prst="rect"/>
@@ -12284,7 +12284,7 @@
         </p:nvSpPr>
         <p:spPr>
           <a:xfrm rot="0" flipH="0" flipV="0">
-            <a:off x="9515475" y="3810000"/>
+            <a:off x="9515475" y="3118988"/>
             <a:ext cx="1743075" cy="1066800"/>
           </a:xfrm>
           <a:prstGeom prst="roundRect">
@@ -12310,7 +12310,7 @@
         </p:nvSpPr>
         <p:spPr>
           <a:xfrm rot="0" flipH="0" flipV="0">
-            <a:off x="9620250" y="3895725"/>
+            <a:off x="9620250" y="3204713"/>
             <a:ext cx="1533525" cy="895350"/>
           </a:xfrm>
           <a:prstGeom prst="rect"/>
@@ -12347,7 +12347,7 @@
         </p:nvSpPr>
         <p:spPr>
           <a:xfrm rot="0" flipH="0" flipV="0">
-            <a:off x="800100" y="5143500"/>
+            <a:off x="800100" y="4461037"/>
             <a:ext cx="6838950" cy="819150"/>
           </a:xfrm>
           <a:prstGeom prst="roundRect">
@@ -12378,7 +12378,7 @@
         </p:nvSpPr>
         <p:spPr>
           <a:xfrm rot="0" flipH="0" flipV="0">
-            <a:off x="990600" y="5267325"/>
+            <a:off x="990600" y="4584862"/>
             <a:ext cx="6457950" cy="571500"/>
           </a:xfrm>
           <a:prstGeom prst="rect"/>
@@ -12425,7 +12425,7 @@
         </p:nvSpPr>
         <p:spPr>
           <a:xfrm rot="0" flipH="0" flipV="0">
-            <a:off x="7772400" y="5143500"/>
+            <a:off x="7772400" y="4461037"/>
             <a:ext cx="3619500" cy="819150"/>
           </a:xfrm>
           <a:custGeom>
@@ -12465,7 +12465,7 @@
         </p:nvSpPr>
         <p:spPr>
           <a:xfrm rot="0" flipH="0" flipV="0">
-            <a:off x="7943850" y="5172075"/>
+            <a:off x="7943850" y="4489612"/>
             <a:ext cx="3448050" cy="771525"/>
           </a:xfrm>
           <a:prstGeom prst="rect"/>
@@ -13431,7 +13431,7 @@
         </p:nvSpPr>
         <p:spPr>
           <a:xfrm rot="0" flipH="0" flipV="0">
-            <a:off x="800100" y="4343400"/>
+            <a:off x="800100" y="3910724"/>
             <a:ext cx="1905000" cy="571500"/>
           </a:xfrm>
           <a:prstGeom prst="roundRect">
@@ -13457,7 +13457,7 @@
         </p:nvSpPr>
         <p:spPr>
           <a:xfrm rot="0" flipH="0" flipV="0">
-            <a:off x="971550" y="4457700"/>
+            <a:off x="971550" y="4025024"/>
             <a:ext cx="1562100" cy="342900"/>
           </a:xfrm>
           <a:prstGeom prst="rect"/>
@@ -13494,7 +13494,7 @@
         </p:nvSpPr>
         <p:spPr>
           <a:xfrm rot="0" flipH="0" flipV="0">
-            <a:off x="2819400" y="4333875"/>
+            <a:off x="2819400" y="3901199"/>
             <a:ext cx="8572500" cy="590550"/>
           </a:xfrm>
           <a:prstGeom prst="rect"/>
@@ -13552,7 +13552,7 @@
         <p:spPr>
           <a:xfrm rot="0" flipH="0" flipV="0">
             <a:off x="800100" y="2162175"/>
-            <a:ext cx="1666875" cy="1962150"/>
+            <a:ext cx="1666875" cy="1529474"/>
           </a:xfrm>
           <a:prstGeom prst="roundRect">
             <a:avLst>
@@ -13578,7 +13578,7 @@
         <p:spPr>
           <a:xfrm rot="0" flipH="0" flipV="0">
             <a:off x="800100" y="2162175"/>
-            <a:ext cx="1666875" cy="1962150"/>
+            <a:ext cx="1666875" cy="1529474"/>
           </a:xfrm>
           <a:custGeom>
             <a:pathLst>
@@ -13695,7 +13695,7 @@
         </p:nvSpPr>
         <p:spPr>
           <a:xfrm rot="0" flipH="0" flipV="0">
-            <a:off x="933450" y="3371850"/>
+            <a:off x="933450" y="2911575"/>
             <a:ext cx="1400175" cy="228600"/>
           </a:xfrm>
           <a:prstGeom prst="rect"/>
@@ -13730,7 +13730,7 @@
         </p:nvSpPr>
         <p:spPr>
           <a:xfrm rot="0" flipH="0" flipV="0">
-            <a:off x="933450" y="3657600"/>
+            <a:off x="933450" y="3197325"/>
             <a:ext cx="1400175" cy="314325"/>
           </a:xfrm>
           <a:prstGeom prst="rect"/>
@@ -13768,7 +13768,7 @@
         <p:spPr>
           <a:xfrm rot="0" flipH="0" flipV="0">
             <a:off x="2581275" y="2162175"/>
-            <a:ext cx="1676400" cy="1962150"/>
+            <a:ext cx="1676400" cy="1529474"/>
           </a:xfrm>
           <a:prstGeom prst="roundRect">
             <a:avLst>
@@ -13794,7 +13794,7 @@
         <p:spPr>
           <a:xfrm rot="0" flipH="0" flipV="0">
             <a:off x="2581275" y="2162175"/>
-            <a:ext cx="1676400" cy="1962150"/>
+            <a:ext cx="1676400" cy="1529474"/>
           </a:xfrm>
           <a:custGeom>
             <a:pathLst>
@@ -13911,7 +13911,7 @@
         </p:nvSpPr>
         <p:spPr>
           <a:xfrm rot="0" flipH="0" flipV="0">
-            <a:off x="2714625" y="3524250"/>
+            <a:off x="2714625" y="2911575"/>
             <a:ext cx="1409700" cy="228600"/>
           </a:xfrm>
           <a:prstGeom prst="rect"/>
@@ -13946,7 +13946,7 @@
         </p:nvSpPr>
         <p:spPr>
           <a:xfrm rot="0" flipH="0" flipV="0">
-            <a:off x="2714625" y="3810000"/>
+            <a:off x="2714625" y="3197325"/>
             <a:ext cx="1409700" cy="161925"/>
           </a:xfrm>
           <a:prstGeom prst="rect"/>
@@ -13982,7 +13982,7 @@
         <p:spPr>
           <a:xfrm rot="0" flipH="0" flipV="0">
             <a:off x="4371975" y="2162175"/>
-            <a:ext cx="1666875" cy="1962150"/>
+            <a:ext cx="1666875" cy="1529474"/>
           </a:xfrm>
           <a:prstGeom prst="roundRect">
             <a:avLst>
@@ -14008,7 +14008,7 @@
         <p:spPr>
           <a:xfrm rot="0" flipH="0" flipV="0">
             <a:off x="4371975" y="2162175"/>
-            <a:ext cx="1666875" cy="1962150"/>
+            <a:ext cx="1666875" cy="1529474"/>
           </a:xfrm>
           <a:custGeom>
             <a:pathLst>
@@ -14125,7 +14125,7 @@
         </p:nvSpPr>
         <p:spPr>
           <a:xfrm rot="0" flipH="0" flipV="0">
-            <a:off x="4505325" y="3524250"/>
+            <a:off x="4505325" y="2911575"/>
             <a:ext cx="1400175" cy="228600"/>
           </a:xfrm>
           <a:prstGeom prst="rect"/>
@@ -14160,7 +14160,7 @@
         </p:nvSpPr>
         <p:spPr>
           <a:xfrm rot="0" flipH="0" flipV="0">
-            <a:off x="4505325" y="3810000"/>
+            <a:off x="4505325" y="3197325"/>
             <a:ext cx="1400175" cy="161925"/>
           </a:xfrm>
           <a:prstGeom prst="rect"/>
@@ -14196,7 +14196,7 @@
         <p:spPr>
           <a:xfrm rot="0" flipH="0" flipV="0">
             <a:off x="6153150" y="2162175"/>
-            <a:ext cx="1666875" cy="1962150"/>
+            <a:ext cx="1666875" cy="1529474"/>
           </a:xfrm>
           <a:prstGeom prst="roundRect">
             <a:avLst>
@@ -14222,7 +14222,7 @@
         <p:spPr>
           <a:xfrm rot="0" flipH="0" flipV="0">
             <a:off x="6153150" y="2162175"/>
-            <a:ext cx="1666875" cy="1962150"/>
+            <a:ext cx="1666875" cy="1529474"/>
           </a:xfrm>
           <a:custGeom>
             <a:pathLst>
@@ -14339,7 +14339,7 @@
         </p:nvSpPr>
         <p:spPr>
           <a:xfrm rot="0" flipH="0" flipV="0">
-            <a:off x="6286500" y="3524250"/>
+            <a:off x="6286500" y="2911575"/>
             <a:ext cx="1400175" cy="228600"/>
           </a:xfrm>
           <a:prstGeom prst="rect"/>
@@ -14374,7 +14374,7 @@
         </p:nvSpPr>
         <p:spPr>
           <a:xfrm rot="0" flipH="0" flipV="0">
-            <a:off x="6286500" y="3810000"/>
+            <a:off x="6286500" y="3197325"/>
             <a:ext cx="1400175" cy="161925"/>
           </a:xfrm>
           <a:prstGeom prst="rect"/>
@@ -14410,7 +14410,7 @@
         <p:spPr>
           <a:xfrm rot="0" flipH="0" flipV="0">
             <a:off x="7934325" y="2162175"/>
-            <a:ext cx="1676400" cy="1962150"/>
+            <a:ext cx="1676400" cy="1529474"/>
           </a:xfrm>
           <a:prstGeom prst="roundRect">
             <a:avLst>
@@ -14436,7 +14436,7 @@
         <p:spPr>
           <a:xfrm rot="0" flipH="0" flipV="0">
             <a:off x="7934325" y="2162175"/>
-            <a:ext cx="1676400" cy="1962150"/>
+            <a:ext cx="1676400" cy="1529474"/>
           </a:xfrm>
           <a:custGeom>
             <a:pathLst>
@@ -14553,7 +14553,7 @@
         </p:nvSpPr>
         <p:spPr>
           <a:xfrm rot="0" flipH="0" flipV="0">
-            <a:off x="8067675" y="3371850"/>
+            <a:off x="8067675" y="2911575"/>
             <a:ext cx="1409700" cy="228600"/>
           </a:xfrm>
           <a:prstGeom prst="rect"/>
@@ -14588,7 +14588,7 @@
         </p:nvSpPr>
         <p:spPr>
           <a:xfrm rot="0" flipH="0" flipV="0">
-            <a:off x="8067675" y="3657600"/>
+            <a:off x="8067675" y="3197325"/>
             <a:ext cx="1409700" cy="314325"/>
           </a:xfrm>
           <a:prstGeom prst="rect"/>
@@ -14626,7 +14626,7 @@
         <p:spPr>
           <a:xfrm rot="0" flipH="0" flipV="0">
             <a:off x="9725025" y="2162175"/>
-            <a:ext cx="1666875" cy="1962150"/>
+            <a:ext cx="1666875" cy="1529474"/>
           </a:xfrm>
           <a:prstGeom prst="roundRect">
             <a:avLst>
@@ -14652,7 +14652,7 @@
         <p:spPr>
           <a:xfrm rot="0" flipH="0" flipV="0">
             <a:off x="9725025" y="2162175"/>
-            <a:ext cx="1666875" cy="1962150"/>
+            <a:ext cx="1666875" cy="1529474"/>
           </a:xfrm>
           <a:custGeom>
             <a:pathLst>
@@ -14769,7 +14769,7 @@
         </p:nvSpPr>
         <p:spPr>
           <a:xfrm rot="0" flipH="0" flipV="0">
-            <a:off x="9858375" y="3524250"/>
+            <a:off x="9858375" y="2911575"/>
             <a:ext cx="1400175" cy="228600"/>
           </a:xfrm>
           <a:prstGeom prst="rect"/>
@@ -14804,7 +14804,7 @@
         </p:nvSpPr>
         <p:spPr>
           <a:xfrm rot="0" flipH="0" flipV="0">
-            <a:off x="9858375" y="3810000"/>
+            <a:off x="9858375" y="3197325"/>
             <a:ext cx="1400175" cy="161925"/>
           </a:xfrm>
           <a:prstGeom prst="rect"/>
@@ -17850,8 +17850,8 @@
         </p:nvSpPr>
         <p:spPr>
           <a:xfrm rot="0" flipH="0" flipV="0">
-            <a:off x="800100" y="1123950"/>
-            <a:ext cx="3419475" cy="3905250"/>
+            <a:off x="800100" y="2155275"/>
+            <a:ext cx="3419475" cy="1920000"/>
           </a:xfrm>
           <a:prstGeom prst="roundRect">
             <a:avLst>
@@ -17876,8 +17876,8 @@
         </p:nvSpPr>
         <p:spPr>
           <a:xfrm rot="0" flipH="0" flipV="0">
-            <a:off x="800100" y="1123950"/>
-            <a:ext cx="3419475" cy="3905250"/>
+            <a:off x="800100" y="2155275"/>
+            <a:ext cx="3419475" cy="1920000"/>
           </a:xfrm>
           <a:custGeom>
             <a:pathLst>
@@ -17933,7 +17933,7 @@
         </p:nvSpPr>
         <p:spPr>
           <a:xfrm rot="0" flipH="0" flipV="0">
-            <a:off x="971550" y="1276350"/>
+            <a:off x="971550" y="2307675"/>
             <a:ext cx="361950" cy="361950"/>
           </a:xfrm>
           <a:prstGeom prst="roundRect">
@@ -17973,7 +17973,7 @@
         </p:blipFill>
         <p:spPr>
           <a:xfrm rot="0" flipH="0" flipV="0">
-            <a:off x="1066800" y="1371600"/>
+            <a:off x="1066800" y="2402925"/>
             <a:ext cx="180975" cy="180975"/>
           </a:xfrm>
           <a:prstGeom prst="rect">
@@ -17990,7 +17990,7 @@
         </p:nvSpPr>
         <p:spPr>
           <a:xfrm rot="0" flipH="0" flipV="0">
-            <a:off x="1428750" y="1285875"/>
+            <a:off x="1428750" y="2317200"/>
             <a:ext cx="981075" cy="209550"/>
           </a:xfrm>
           <a:prstGeom prst="rect"/>
@@ -18025,7 +18025,7 @@
         </p:nvSpPr>
         <p:spPr>
           <a:xfrm rot="0" flipH="0" flipV="0">
-            <a:off x="1428750" y="1495425"/>
+            <a:off x="1428750" y="2526750"/>
             <a:ext cx="981075" cy="142875"/>
           </a:xfrm>
           <a:prstGeom prst="rect"/>
@@ -18060,7 +18060,7 @@
         </p:nvSpPr>
         <p:spPr>
           <a:xfrm rot="0" flipH="0" flipV="0">
-            <a:off x="971550" y="1733550"/>
+            <a:off x="971550" y="2764875"/>
             <a:ext cx="3076575" cy="771525"/>
           </a:xfrm>
           <a:prstGeom prst="rect"/>
@@ -18097,7 +18097,7 @@
         </p:nvSpPr>
         <p:spPr>
           <a:xfrm rot="0" flipH="0" flipV="0">
-            <a:off x="971550" y="4695825"/>
+            <a:off x="971550" y="3752400"/>
             <a:ext cx="3076575" cy="142875"/>
           </a:xfrm>
           <a:prstGeom prst="rect"/>
@@ -18132,8 +18132,8 @@
         </p:nvSpPr>
         <p:spPr>
           <a:xfrm rot="0" flipH="0" flipV="0">
-            <a:off x="4391025" y="1123950"/>
-            <a:ext cx="3409950" cy="3905250"/>
+            <a:off x="4391025" y="2155275"/>
+            <a:ext cx="3409950" cy="1920000"/>
           </a:xfrm>
           <a:prstGeom prst="roundRect">
             <a:avLst>
@@ -18158,8 +18158,8 @@
         </p:nvSpPr>
         <p:spPr>
           <a:xfrm rot="0" flipH="0" flipV="0">
-            <a:off x="4391025" y="1123950"/>
-            <a:ext cx="3409950" cy="3905250"/>
+            <a:off x="4391025" y="2155275"/>
+            <a:ext cx="3409950" cy="1920000"/>
           </a:xfrm>
           <a:custGeom>
             <a:pathLst>
@@ -18215,7 +18215,7 @@
         </p:nvSpPr>
         <p:spPr>
           <a:xfrm rot="0" flipH="0" flipV="0">
-            <a:off x="4562475" y="1276350"/>
+            <a:off x="4562475" y="2307675"/>
             <a:ext cx="361950" cy="361950"/>
           </a:xfrm>
           <a:prstGeom prst="roundRect">
@@ -18255,7 +18255,7 @@
         </p:blipFill>
         <p:spPr>
           <a:xfrm rot="0" flipH="0" flipV="0">
-            <a:off x="4657725" y="1371600"/>
+            <a:off x="4657725" y="2402925"/>
             <a:ext cx="180975" cy="180975"/>
           </a:xfrm>
           <a:prstGeom prst="rect">
@@ -18272,7 +18272,7 @@
         </p:nvSpPr>
         <p:spPr>
           <a:xfrm rot="0" flipH="0" flipV="0">
-            <a:off x="5019675" y="1285875"/>
+            <a:off x="5019675" y="2317200"/>
             <a:ext cx="1285875" cy="209550"/>
           </a:xfrm>
           <a:prstGeom prst="rect"/>
@@ -18307,7 +18307,7 @@
         </p:nvSpPr>
         <p:spPr>
           <a:xfrm rot="0" flipH="0" flipV="0">
-            <a:off x="5019675" y="1495425"/>
+            <a:off x="5019675" y="2526750"/>
             <a:ext cx="1285875" cy="142875"/>
           </a:xfrm>
           <a:prstGeom prst="rect"/>
@@ -18342,7 +18342,7 @@
         </p:nvSpPr>
         <p:spPr>
           <a:xfrm rot="0" flipH="0" flipV="0">
-            <a:off x="4562475" y="1733550"/>
+            <a:off x="4562475" y="2764875"/>
             <a:ext cx="3067050" cy="514350"/>
           </a:xfrm>
           <a:prstGeom prst="rect"/>
@@ -18379,7 +18379,7 @@
         </p:nvSpPr>
         <p:spPr>
           <a:xfrm rot="0" flipH="0" flipV="0">
-            <a:off x="4562475" y="4695825"/>
+            <a:off x="4562475" y="3752400"/>
             <a:ext cx="3067050" cy="142875"/>
           </a:xfrm>
           <a:prstGeom prst="rect"/>
@@ -18414,8 +18414,8 @@
         </p:nvSpPr>
         <p:spPr>
           <a:xfrm rot="0" flipH="0" flipV="0">
-            <a:off x="7972425" y="1123950"/>
-            <a:ext cx="3419475" cy="3905250"/>
+            <a:off x="7972425" y="2155275"/>
+            <a:ext cx="3419475" cy="1920000"/>
           </a:xfrm>
           <a:prstGeom prst="roundRect">
             <a:avLst>
@@ -18440,8 +18440,8 @@
         </p:nvSpPr>
         <p:spPr>
           <a:xfrm rot="0" flipH="0" flipV="0">
-            <a:off x="7972425" y="1123950"/>
-            <a:ext cx="3419475" cy="3905250"/>
+            <a:off x="7972425" y="2155275"/>
+            <a:ext cx="3419475" cy="1920000"/>
           </a:xfrm>
           <a:custGeom>
             <a:pathLst>
@@ -18497,7 +18497,7 @@
         </p:nvSpPr>
         <p:spPr>
           <a:xfrm rot="0" flipH="0" flipV="0">
-            <a:off x="8143875" y="1276350"/>
+            <a:off x="8143875" y="2307675"/>
             <a:ext cx="361950" cy="361950"/>
           </a:xfrm>
           <a:prstGeom prst="roundRect">
@@ -18537,7 +18537,7 @@
         </p:blipFill>
         <p:spPr>
           <a:xfrm rot="0" flipH="0" flipV="0">
-            <a:off x="8239125" y="1371600"/>
+            <a:off x="8239125" y="2402925"/>
             <a:ext cx="180975" cy="180975"/>
           </a:xfrm>
           <a:prstGeom prst="rect">
@@ -18554,7 +18554,7 @@
         </p:nvSpPr>
         <p:spPr>
           <a:xfrm rot="0" flipH="0" flipV="0">
-            <a:off x="8601075" y="1285875"/>
+            <a:off x="8601075" y="2317200"/>
             <a:ext cx="1152525" cy="209550"/>
           </a:xfrm>
           <a:prstGeom prst="rect"/>
@@ -18589,7 +18589,7 @@
         </p:nvSpPr>
         <p:spPr>
           <a:xfrm rot="0" flipH="0" flipV="0">
-            <a:off x="8601075" y="1495425"/>
+            <a:off x="8601075" y="2526750"/>
             <a:ext cx="1152525" cy="142875"/>
           </a:xfrm>
           <a:prstGeom prst="rect"/>
@@ -18624,7 +18624,7 @@
         </p:nvSpPr>
         <p:spPr>
           <a:xfrm rot="0" flipH="0" flipV="0">
-            <a:off x="8143875" y="1733550"/>
+            <a:off x="8143875" y="2764875"/>
             <a:ext cx="3076575" cy="514350"/>
           </a:xfrm>
           <a:prstGeom prst="rect"/>
@@ -18661,7 +18661,7 @@
         </p:nvSpPr>
         <p:spPr>
           <a:xfrm rot="0" flipH="0" flipV="0">
-            <a:off x="8143875" y="4695825"/>
+            <a:off x="8143875" y="3752400"/>
             <a:ext cx="3076575" cy="142875"/>
           </a:xfrm>
           <a:prstGeom prst="rect"/>
@@ -18696,7 +18696,7 @@
         </p:nvSpPr>
         <p:spPr>
           <a:xfrm rot="0" flipH="0" flipV="0">
-            <a:off x="800100" y="5143500"/>
+            <a:off x="800100" y="4189575"/>
             <a:ext cx="5467350" cy="819150"/>
           </a:xfrm>
           <a:prstGeom prst="roundRect">
@@ -18727,7 +18727,7 @@
         </p:nvSpPr>
         <p:spPr>
           <a:xfrm rot="0" flipH="0" flipV="0">
-            <a:off x="990600" y="5267325"/>
+            <a:off x="990600" y="4313400"/>
             <a:ext cx="5086350" cy="571500"/>
           </a:xfrm>
           <a:prstGeom prst="rect"/>
@@ -18750,7 +18750,7 @@
                 <a:latin typeface="Inter"/>
                 <a:ea typeface="Inter"/>
               </a:rPr>
-              <a:t>After detection, three options:</a:t>
+              <a:t>After detection, three options: </a:t>
             </a:r>
             <a:r>
               <a:rPr lang="en-US" sz="1125" b="1">
@@ -18824,7 +18824,7 @@
         </p:nvSpPr>
         <p:spPr>
           <a:xfrm rot="0" flipH="0" flipV="0">
-            <a:off x="6419850" y="5143500"/>
+            <a:off x="6419850" y="4189575"/>
             <a:ext cx="5010150" cy="819150"/>
           </a:xfrm>
           <a:custGeom>
@@ -18864,7 +18864,7 @@
         </p:nvSpPr>
         <p:spPr>
           <a:xfrm rot="0" flipH="0" flipV="0">
-            <a:off x="6591300" y="5286375"/>
+            <a:off x="6591300" y="4332450"/>
             <a:ext cx="4800600" cy="533400"/>
           </a:xfrm>
           <a:prstGeom prst="rect"/>
@@ -20476,8 +20476,8 @@
         </p:nvSpPr>
         <p:spPr>
           <a:xfrm rot="0" flipH="0" flipV="0">
-            <a:off x="800100" y="3181350"/>
-            <a:ext cx="5219700" cy="2762250"/>
+            <a:off x="800100" y="3860813"/>
+            <a:ext cx="5219700" cy="1480724"/>
           </a:xfrm>
           <a:prstGeom prst="roundRect">
             <a:avLst>
@@ -20507,7 +20507,7 @@
         </p:nvSpPr>
         <p:spPr>
           <a:xfrm rot="0" flipH="0" flipV="0">
-            <a:off x="1009650" y="3333750"/>
+            <a:off x="1009650" y="4013213"/>
             <a:ext cx="4800600" cy="190500"/>
           </a:xfrm>
           <a:prstGeom prst="rect"/>
@@ -20542,7 +20542,7 @@
         </p:nvSpPr>
         <p:spPr>
           <a:xfrm rot="0" flipH="0" flipV="0">
-            <a:off x="1009650" y="3600450"/>
+            <a:off x="1009650" y="4279913"/>
             <a:ext cx="4800600" cy="561975"/>
           </a:xfrm>
           <a:prstGeom prst="rect"/>
@@ -20609,8 +20609,8 @@
         </p:nvSpPr>
         <p:spPr>
           <a:xfrm rot="0" flipH="0" flipV="0">
-            <a:off x="6172200" y="3181350"/>
-            <a:ext cx="5219700" cy="2762250"/>
+            <a:off x="6172200" y="3860813"/>
+            <a:ext cx="5219700" cy="1480724"/>
           </a:xfrm>
           <a:prstGeom prst="roundRect">
             <a:avLst>
@@ -20635,7 +20635,7 @@
         </p:nvSpPr>
         <p:spPr>
           <a:xfrm rot="0" flipH="0" flipV="0">
-            <a:off x="6381750" y="3333750"/>
+            <a:off x="6381750" y="4013213"/>
             <a:ext cx="4800600" cy="190500"/>
           </a:xfrm>
           <a:prstGeom prst="rect"/>
@@ -20670,7 +20670,7 @@
         </p:nvSpPr>
         <p:spPr>
           <a:xfrm rot="0" flipH="0" flipV="0">
-            <a:off x="6381750" y="3609975"/>
+            <a:off x="6381750" y="4289438"/>
             <a:ext cx="104775" cy="152400"/>
           </a:xfrm>
           <a:prstGeom prst="rect"/>
@@ -20715,7 +20715,7 @@
         </p:nvSpPr>
         <p:spPr>
           <a:xfrm rot="0" flipH="0" flipV="0">
-            <a:off x="6562725" y="3600450"/>
+            <a:off x="6562725" y="4279913"/>
             <a:ext cx="4419600" cy="238125"/>
           </a:xfrm>
           <a:prstGeom prst="rect"/>
@@ -20752,7 +20752,7 @@
         </p:nvSpPr>
         <p:spPr>
           <a:xfrm rot="0" flipH="0" flipV="0">
-            <a:off x="6381750" y="3895725"/>
+            <a:off x="6381750" y="4575188"/>
             <a:ext cx="104775" cy="152400"/>
           </a:xfrm>
           <a:prstGeom prst="rect"/>
@@ -20797,7 +20797,7 @@
         </p:nvSpPr>
         <p:spPr>
           <a:xfrm rot="0" flipH="0" flipV="0">
-            <a:off x="6562725" y="3886200"/>
+            <a:off x="6562725" y="4565663"/>
             <a:ext cx="2085975" cy="238125"/>
           </a:xfrm>
           <a:prstGeom prst="rect"/>
@@ -20834,7 +20834,7 @@
         </p:nvSpPr>
         <p:spPr>
           <a:xfrm rot="0" flipH="0" flipV="0">
-            <a:off x="6381750" y="4181475"/>
+            <a:off x="6381750" y="4860938"/>
             <a:ext cx="104775" cy="152400"/>
           </a:xfrm>
           <a:prstGeom prst="rect"/>
@@ -20879,7 +20879,7 @@
         </p:nvSpPr>
         <p:spPr>
           <a:xfrm rot="0" flipH="0" flipV="0">
-            <a:off x="6562725" y="4171950"/>
+            <a:off x="6562725" y="4851413"/>
             <a:ext cx="2905125" cy="238125"/>
           </a:xfrm>
           <a:prstGeom prst="rect"/>
@@ -20916,7 +20916,7 @@
         </p:nvSpPr>
         <p:spPr>
           <a:xfrm rot="0" flipH="0" flipV="0">
-            <a:off x="800100" y="1143000"/>
+            <a:off x="800100" y="1822463"/>
             <a:ext cx="2028825" cy="1866900"/>
           </a:xfrm>
           <a:prstGeom prst="roundRect">
@@ -20942,7 +20942,7 @@
         </p:nvSpPr>
         <p:spPr>
           <a:xfrm rot="0" flipH="0" flipV="0">
-            <a:off x="800100" y="1143000"/>
+            <a:off x="800100" y="1822463"/>
             <a:ext cx="2028825" cy="1866900"/>
           </a:xfrm>
           <a:custGeom>
@@ -20999,7 +20999,7 @@
         </p:nvSpPr>
         <p:spPr>
           <a:xfrm rot="0" flipH="0" flipV="0">
-            <a:off x="914400" y="1276350"/>
+            <a:off x="914400" y="1955813"/>
             <a:ext cx="323850" cy="323850"/>
           </a:xfrm>
           <a:prstGeom prst="roundRect">
@@ -21025,7 +21025,7 @@
         </p:nvSpPr>
         <p:spPr>
           <a:xfrm rot="0" flipH="0" flipV="0">
-            <a:off x="1019175" y="1343025"/>
+            <a:off x="1019175" y="2022488"/>
             <a:ext cx="114300" cy="190500"/>
           </a:xfrm>
           <a:prstGeom prst="rect"/>
@@ -21060,7 +21060,7 @@
         </p:nvSpPr>
         <p:spPr>
           <a:xfrm rot="0" flipH="0" flipV="0">
-            <a:off x="2162175" y="1343025"/>
+            <a:off x="2162175" y="2022488"/>
             <a:ext cx="552450" cy="200025"/>
           </a:xfrm>
           <a:prstGeom prst="roundRect">
@@ -21086,7 +21086,7 @@
         </p:nvSpPr>
         <p:spPr>
           <a:xfrm rot="0" flipH="0" flipV="0">
-            <a:off x="2247900" y="1371600"/>
+            <a:off x="2247900" y="2051063"/>
             <a:ext cx="381000" cy="142875"/>
           </a:xfrm>
           <a:prstGeom prst="rect"/>
@@ -21135,7 +21135,7 @@
         </p:blipFill>
         <p:spPr>
           <a:xfrm rot="0" flipH="0" flipV="0">
-            <a:off x="914400" y="2152650"/>
+            <a:off x="914400" y="2832113"/>
             <a:ext cx="228600" cy="228600"/>
           </a:xfrm>
           <a:prstGeom prst="rect">
@@ -21152,7 +21152,7 @@
         </p:nvSpPr>
         <p:spPr>
           <a:xfrm rot="0" flipH="0" flipV="0">
-            <a:off x="914400" y="2438400"/>
+            <a:off x="914400" y="3117863"/>
             <a:ext cx="1800225" cy="200025"/>
           </a:xfrm>
           <a:prstGeom prst="rect"/>
@@ -21187,7 +21187,7 @@
         </p:nvSpPr>
         <p:spPr>
           <a:xfrm rot="0" flipH="0" flipV="0">
-            <a:off x="914400" y="2667000"/>
+            <a:off x="914400" y="3346463"/>
             <a:ext cx="1800225" cy="209550"/>
           </a:xfrm>
           <a:prstGeom prst="rect"/>
@@ -21222,7 +21222,7 @@
         </p:nvSpPr>
         <p:spPr>
           <a:xfrm rot="0" flipH="0" flipV="0">
-            <a:off x="2943225" y="1143000"/>
+            <a:off x="2943225" y="1822463"/>
             <a:ext cx="2028825" cy="1866900"/>
           </a:xfrm>
           <a:prstGeom prst="roundRect">
@@ -21248,7 +21248,7 @@
         </p:nvSpPr>
         <p:spPr>
           <a:xfrm rot="0" flipH="0" flipV="0">
-            <a:off x="2943225" y="1143000"/>
+            <a:off x="2943225" y="1822463"/>
             <a:ext cx="2028825" cy="1866900"/>
           </a:xfrm>
           <a:custGeom>
@@ -21305,7 +21305,7 @@
         </p:nvSpPr>
         <p:spPr>
           <a:xfrm rot="0" flipH="0" flipV="0">
-            <a:off x="3057525" y="1276350"/>
+            <a:off x="3057525" y="1955813"/>
             <a:ext cx="323850" cy="323850"/>
           </a:xfrm>
           <a:prstGeom prst="roundRect">
@@ -21331,7 +21331,7 @@
         </p:nvSpPr>
         <p:spPr>
           <a:xfrm rot="0" flipH="0" flipV="0">
-            <a:off x="3162300" y="1343025"/>
+            <a:off x="3162300" y="2022488"/>
             <a:ext cx="114300" cy="190500"/>
           </a:xfrm>
           <a:prstGeom prst="rect"/>
@@ -21366,7 +21366,7 @@
         </p:nvSpPr>
         <p:spPr>
           <a:xfrm rot="0" flipH="0" flipV="0">
-            <a:off x="4305300" y="1343025"/>
+            <a:off x="4305300" y="2022488"/>
             <a:ext cx="552450" cy="200025"/>
           </a:xfrm>
           <a:prstGeom prst="roundRect">
@@ -21392,7 +21392,7 @@
         </p:nvSpPr>
         <p:spPr>
           <a:xfrm rot="0" flipH="0" flipV="0">
-            <a:off x="4391025" y="1371600"/>
+            <a:off x="4391025" y="2051063"/>
             <a:ext cx="381000" cy="142875"/>
           </a:xfrm>
           <a:prstGeom prst="rect"/>
@@ -21441,7 +21441,7 @@
         </p:blipFill>
         <p:spPr>
           <a:xfrm rot="0" flipH="0" flipV="0">
-            <a:off x="3057525" y="1943100"/>
+            <a:off x="3057525" y="2622563"/>
             <a:ext cx="228600" cy="228600"/>
           </a:xfrm>
           <a:prstGeom prst="rect">
@@ -21458,7 +21458,7 @@
         </p:nvSpPr>
         <p:spPr>
           <a:xfrm rot="0" flipH="0" flipV="0">
-            <a:off x="3057525" y="2228850"/>
+            <a:off x="3057525" y="2908313"/>
             <a:ext cx="1800225" cy="200025"/>
           </a:xfrm>
           <a:prstGeom prst="rect"/>
@@ -21493,7 +21493,7 @@
         </p:nvSpPr>
         <p:spPr>
           <a:xfrm rot="0" flipH="0" flipV="0">
-            <a:off x="3057525" y="2457450"/>
+            <a:off x="3057525" y="3136913"/>
             <a:ext cx="1800225" cy="419100"/>
           </a:xfrm>
           <a:prstGeom prst="rect"/>
@@ -21530,7 +21530,7 @@
         </p:nvSpPr>
         <p:spPr>
           <a:xfrm rot="0" flipH="0" flipV="0">
-            <a:off x="5086350" y="1143000"/>
+            <a:off x="5086350" y="1822463"/>
             <a:ext cx="2019300" cy="1866900"/>
           </a:xfrm>
           <a:prstGeom prst="roundRect">
@@ -21556,7 +21556,7 @@
         </p:nvSpPr>
         <p:spPr>
           <a:xfrm rot="0" flipH="0" flipV="0">
-            <a:off x="5086350" y="1143000"/>
+            <a:off x="5086350" y="1822463"/>
             <a:ext cx="2019300" cy="1866900"/>
           </a:xfrm>
           <a:custGeom>
@@ -21613,7 +21613,7 @@
         </p:nvSpPr>
         <p:spPr>
           <a:xfrm rot="0" flipH="0" flipV="0">
-            <a:off x="5200650" y="1276350"/>
+            <a:off x="5200650" y="1955813"/>
             <a:ext cx="323850" cy="323850"/>
           </a:xfrm>
           <a:prstGeom prst="roundRect">
@@ -21639,7 +21639,7 @@
         </p:nvSpPr>
         <p:spPr>
           <a:xfrm rot="0" flipH="0" flipV="0">
-            <a:off x="5305425" y="1343025"/>
+            <a:off x="5305425" y="2022488"/>
             <a:ext cx="114300" cy="190500"/>
           </a:xfrm>
           <a:prstGeom prst="rect"/>
@@ -21674,7 +21674,7 @@
         </p:nvSpPr>
         <p:spPr>
           <a:xfrm rot="0" flipH="0" flipV="0">
-            <a:off x="6438900" y="1343025"/>
+            <a:off x="6438900" y="2022488"/>
             <a:ext cx="552450" cy="200025"/>
           </a:xfrm>
           <a:prstGeom prst="roundRect">
@@ -21700,7 +21700,7 @@
         </p:nvSpPr>
         <p:spPr>
           <a:xfrm rot="0" flipH="0" flipV="0">
-            <a:off x="6524625" y="1371600"/>
+            <a:off x="6524625" y="2051063"/>
             <a:ext cx="381000" cy="142875"/>
           </a:xfrm>
           <a:prstGeom prst="rect"/>
@@ -21749,7 +21749,7 @@
         </p:blipFill>
         <p:spPr>
           <a:xfrm rot="0" flipH="0" flipV="0">
-            <a:off x="5200650" y="1943100"/>
+            <a:off x="5200650" y="2622563"/>
             <a:ext cx="228600" cy="228600"/>
           </a:xfrm>
           <a:prstGeom prst="rect">
@@ -21766,7 +21766,7 @@
         </p:nvSpPr>
         <p:spPr>
           <a:xfrm rot="0" flipH="0" flipV="0">
-            <a:off x="5200650" y="2228850"/>
+            <a:off x="5200650" y="2908313"/>
             <a:ext cx="1790700" cy="200025"/>
           </a:xfrm>
           <a:prstGeom prst="rect"/>
@@ -21801,7 +21801,7 @@
         </p:nvSpPr>
         <p:spPr>
           <a:xfrm rot="0" flipH="0" flipV="0">
-            <a:off x="5200650" y="2457450"/>
+            <a:off x="5200650" y="3136913"/>
             <a:ext cx="1790700" cy="419100"/>
           </a:xfrm>
           <a:prstGeom prst="rect"/>
@@ -21838,7 +21838,7 @@
         </p:nvSpPr>
         <p:spPr>
           <a:xfrm rot="0" flipH="0" flipV="0">
-            <a:off x="7219950" y="1143000"/>
+            <a:off x="7219950" y="1822463"/>
             <a:ext cx="2028825" cy="1866900"/>
           </a:xfrm>
           <a:prstGeom prst="roundRect">
@@ -21864,7 +21864,7 @@
         </p:nvSpPr>
         <p:spPr>
           <a:xfrm rot="0" flipH="0" flipV="0">
-            <a:off x="7219950" y="1143000"/>
+            <a:off x="7219950" y="1822463"/>
             <a:ext cx="2028825" cy="1866900"/>
           </a:xfrm>
           <a:custGeom>
@@ -21921,7 +21921,7 @@
         </p:nvSpPr>
         <p:spPr>
           <a:xfrm rot="0" flipH="0" flipV="0">
-            <a:off x="7334250" y="1276350"/>
+            <a:off x="7334250" y="1955813"/>
             <a:ext cx="323850" cy="323850"/>
           </a:xfrm>
           <a:prstGeom prst="roundRect">
@@ -21947,7 +21947,7 @@
         </p:nvSpPr>
         <p:spPr>
           <a:xfrm rot="0" flipH="0" flipV="0">
-            <a:off x="7439025" y="1343025"/>
+            <a:off x="7439025" y="2022488"/>
             <a:ext cx="114300" cy="190500"/>
           </a:xfrm>
           <a:prstGeom prst="rect"/>
@@ -21982,7 +21982,7 @@
         </p:nvSpPr>
         <p:spPr>
           <a:xfrm rot="0" flipH="0" flipV="0">
-            <a:off x="8582025" y="1343025"/>
+            <a:off x="8582025" y="2022488"/>
             <a:ext cx="552450" cy="200025"/>
           </a:xfrm>
           <a:prstGeom prst="roundRect">
@@ -22008,7 +22008,7 @@
         </p:nvSpPr>
         <p:spPr>
           <a:xfrm rot="0" flipH="0" flipV="0">
-            <a:off x="8667750" y="1371600"/>
+            <a:off x="8667750" y="2051063"/>
             <a:ext cx="381000" cy="142875"/>
           </a:xfrm>
           <a:prstGeom prst="rect"/>
@@ -22057,7 +22057,7 @@
         </p:blipFill>
         <p:spPr>
           <a:xfrm rot="0" flipH="0" flipV="0">
-            <a:off x="7334250" y="2152650"/>
+            <a:off x="7334250" y="2832113"/>
             <a:ext cx="228600" cy="228600"/>
           </a:xfrm>
           <a:prstGeom prst="rect">
@@ -22074,7 +22074,7 @@
         </p:nvSpPr>
         <p:spPr>
           <a:xfrm rot="0" flipH="0" flipV="0">
-            <a:off x="7334250" y="2438400"/>
+            <a:off x="7334250" y="3117863"/>
             <a:ext cx="1800225" cy="200025"/>
           </a:xfrm>
           <a:prstGeom prst="rect"/>
@@ -22109,7 +22109,7 @@
         </p:nvSpPr>
         <p:spPr>
           <a:xfrm rot="0" flipH="0" flipV="0">
-            <a:off x="7334250" y="2667000"/>
+            <a:off x="7334250" y="3346463"/>
             <a:ext cx="1800225" cy="209550"/>
           </a:xfrm>
           <a:prstGeom prst="rect"/>
@@ -22144,7 +22144,7 @@
         </p:nvSpPr>
         <p:spPr>
           <a:xfrm rot="0" flipH="0" flipV="0">
-            <a:off x="9363075" y="1143000"/>
+            <a:off x="9363075" y="1822463"/>
             <a:ext cx="2028825" cy="1866900"/>
           </a:xfrm>
           <a:prstGeom prst="roundRect">
@@ -22170,7 +22170,7 @@
         </p:nvSpPr>
         <p:spPr>
           <a:xfrm rot="0" flipH="0" flipV="0">
-            <a:off x="9363075" y="1143000"/>
+            <a:off x="9363075" y="1822463"/>
             <a:ext cx="2028825" cy="1866900"/>
           </a:xfrm>
           <a:custGeom>
@@ -22227,7 +22227,7 @@
         </p:nvSpPr>
         <p:spPr>
           <a:xfrm rot="0" flipH="0" flipV="0">
-            <a:off x="9477375" y="1276350"/>
+            <a:off x="9477375" y="1955813"/>
             <a:ext cx="323850" cy="323850"/>
           </a:xfrm>
           <a:prstGeom prst="roundRect">
@@ -22253,7 +22253,7 @@
         </p:nvSpPr>
         <p:spPr>
           <a:xfrm rot="0" flipH="0" flipV="0">
-            <a:off x="9591675" y="1343025"/>
+            <a:off x="9591675" y="2022488"/>
             <a:ext cx="104775" cy="190500"/>
           </a:xfrm>
           <a:prstGeom prst="rect"/>
@@ -22288,7 +22288,7 @@
         </p:nvSpPr>
         <p:spPr>
           <a:xfrm rot="0" flipH="0" flipV="0">
-            <a:off x="10791825" y="1343025"/>
+            <a:off x="10791825" y="2022488"/>
             <a:ext cx="485775" cy="200025"/>
           </a:xfrm>
           <a:prstGeom prst="roundRect">
@@ -22314,7 +22314,7 @@
         </p:nvSpPr>
         <p:spPr>
           <a:xfrm rot="0" flipH="0" flipV="0">
-            <a:off x="10877550" y="1371600"/>
+            <a:off x="10877550" y="2051063"/>
             <a:ext cx="314325" cy="142875"/>
           </a:xfrm>
           <a:prstGeom prst="rect"/>
@@ -22363,7 +22363,7 @@
         </p:blipFill>
         <p:spPr>
           <a:xfrm rot="0" flipH="0" flipV="0">
-            <a:off x="9477375" y="2152650"/>
+            <a:off x="9477375" y="2832113"/>
             <a:ext cx="228600" cy="228600"/>
           </a:xfrm>
           <a:prstGeom prst="rect">
@@ -22380,7 +22380,7 @@
         </p:nvSpPr>
         <p:spPr>
           <a:xfrm rot="0" flipH="0" flipV="0">
-            <a:off x="9477375" y="2438400"/>
+            <a:off x="9477375" y="3117863"/>
             <a:ext cx="1800225" cy="200025"/>
           </a:xfrm>
           <a:prstGeom prst="rect"/>
@@ -22415,7 +22415,7 @@
         </p:nvSpPr>
         <p:spPr>
           <a:xfrm rot="0" flipH="0" flipV="0">
-            <a:off x="9477375" y="2667000"/>
+            <a:off x="9477375" y="3346463"/>
             <a:ext cx="1800225" cy="209550"/>
           </a:xfrm>
           <a:prstGeom prst="rect"/>
@@ -22534,7 +22534,7 @@
         </p:blipFill>
         <p:spPr>
           <a:xfrm rot="0" flipH="0" flipV="0">
-            <a:off x="2781300" y="1943100"/>
+            <a:off x="2781300" y="2622563"/>
             <a:ext cx="161925" cy="161925"/>
           </a:xfrm>
           <a:prstGeom prst="rect">
@@ -22565,7 +22565,7 @@
         </p:blipFill>
         <p:spPr>
           <a:xfrm rot="0" flipH="0" flipV="0">
-            <a:off x="4924425" y="1943100"/>
+            <a:off x="4924425" y="2622563"/>
             <a:ext cx="161925" cy="161925"/>
           </a:xfrm>
           <a:prstGeom prst="rect">
@@ -22596,7 +22596,7 @@
         </p:blipFill>
         <p:spPr>
           <a:xfrm rot="0" flipH="0" flipV="0">
-            <a:off x="7058025" y="1943100"/>
+            <a:off x="7058025" y="2622563"/>
             <a:ext cx="161925" cy="161925"/>
           </a:xfrm>
           <a:prstGeom prst="rect">
@@ -22627,7 +22627,7 @@
         </p:blipFill>
         <p:spPr>
           <a:xfrm rot="0" flipH="0" flipV="0">
-            <a:off x="9201150" y="1943100"/>
+            <a:off x="9201150" y="2622563"/>
             <a:ext cx="161925" cy="161925"/>
           </a:xfrm>
           <a:prstGeom prst="rect">
@@ -22786,7 +22786,7 @@
         </p:nvSpPr>
         <p:spPr>
           <a:xfrm rot="0" flipH="0" flipV="0">
-            <a:off x="838200" y="1085850"/>
+            <a:off x="838200" y="1486500"/>
             <a:ext cx="5867400" cy="714375"/>
           </a:xfrm>
           <a:prstGeom prst="roundRect">
@@ -22812,7 +22812,7 @@
         </p:nvSpPr>
         <p:spPr>
           <a:xfrm rot="0" flipH="0" flipV="0">
-            <a:off x="838200" y="1085850"/>
+            <a:off x="838200" y="1486500"/>
             <a:ext cx="5867400" cy="714375"/>
           </a:xfrm>
           <a:custGeom>
@@ -22869,7 +22869,7 @@
         </p:nvSpPr>
         <p:spPr>
           <a:xfrm rot="0" flipH="0" flipV="0">
-            <a:off x="1000125" y="1209675"/>
+            <a:off x="1000125" y="1610325"/>
             <a:ext cx="381000" cy="200025"/>
           </a:xfrm>
           <a:prstGeom prst="rect"/>
@@ -22904,7 +22904,7 @@
         </p:nvSpPr>
         <p:spPr>
           <a:xfrm rot="0" flipH="0" flipV="0">
-            <a:off x="1476375" y="1209675"/>
+            <a:off x="1476375" y="1610325"/>
             <a:ext cx="1285875" cy="200025"/>
           </a:xfrm>
           <a:prstGeom prst="rect"/>
@@ -22939,7 +22939,7 @@
         </p:nvSpPr>
         <p:spPr>
           <a:xfrm rot="0" flipH="0" flipV="0">
-            <a:off x="1000125" y="1438275"/>
+            <a:off x="1000125" y="1838925"/>
             <a:ext cx="5505450" cy="238125"/>
           </a:xfrm>
           <a:prstGeom prst="rect"/>
@@ -22974,7 +22974,7 @@
         </p:nvSpPr>
         <p:spPr>
           <a:xfrm rot="0" flipH="0" flipV="0">
-            <a:off x="838200" y="1914525"/>
+            <a:off x="838200" y="2315175"/>
             <a:ext cx="5867400" cy="714375"/>
           </a:xfrm>
           <a:prstGeom prst="roundRect">
@@ -23000,7 +23000,7 @@
         </p:nvSpPr>
         <p:spPr>
           <a:xfrm rot="0" flipH="0" flipV="0">
-            <a:off x="838200" y="1914525"/>
+            <a:off x="838200" y="2315175"/>
             <a:ext cx="5867400" cy="714375"/>
           </a:xfrm>
           <a:custGeom>
@@ -23057,7 +23057,7 @@
         </p:nvSpPr>
         <p:spPr>
           <a:xfrm rot="0" flipH="0" flipV="0">
-            <a:off x="1000125" y="2038350"/>
+            <a:off x="1000125" y="2439000"/>
             <a:ext cx="381000" cy="200025"/>
           </a:xfrm>
           <a:prstGeom prst="rect"/>
@@ -23092,7 +23092,7 @@
         </p:nvSpPr>
         <p:spPr>
           <a:xfrm rot="0" flipH="0" flipV="0">
-            <a:off x="1476375" y="2038350"/>
+            <a:off x="1476375" y="2439000"/>
             <a:ext cx="1209675" cy="200025"/>
           </a:xfrm>
           <a:prstGeom prst="rect"/>
@@ -23127,7 +23127,7 @@
         </p:nvSpPr>
         <p:spPr>
           <a:xfrm rot="0" flipH="0" flipV="0">
-            <a:off x="1000125" y="2266950"/>
+            <a:off x="1000125" y="2667600"/>
             <a:ext cx="5505450" cy="238125"/>
           </a:xfrm>
           <a:prstGeom prst="rect"/>
@@ -23162,7 +23162,7 @@
         </p:nvSpPr>
         <p:spPr>
           <a:xfrm rot="0" flipH="0" flipV="0">
-            <a:off x="838200" y="2743200"/>
+            <a:off x="838200" y="3143850"/>
             <a:ext cx="5867400" cy="714375"/>
           </a:xfrm>
           <a:prstGeom prst="roundRect">
@@ -23188,7 +23188,7 @@
         </p:nvSpPr>
         <p:spPr>
           <a:xfrm rot="0" flipH="0" flipV="0">
-            <a:off x="838200" y="2743200"/>
+            <a:off x="838200" y="3143850"/>
             <a:ext cx="5867400" cy="714375"/>
           </a:xfrm>
           <a:custGeom>
@@ -23245,7 +23245,7 @@
         </p:nvSpPr>
         <p:spPr>
           <a:xfrm rot="0" flipH="0" flipV="0">
-            <a:off x="1000125" y="2867025"/>
+            <a:off x="1000125" y="3267675"/>
             <a:ext cx="381000" cy="200025"/>
           </a:xfrm>
           <a:prstGeom prst="rect"/>
@@ -23280,7 +23280,7 @@
         </p:nvSpPr>
         <p:spPr>
           <a:xfrm rot="0" flipH="0" flipV="0">
-            <a:off x="1476375" y="2867025"/>
+            <a:off x="1476375" y="3267675"/>
             <a:ext cx="1638300" cy="200025"/>
           </a:xfrm>
           <a:prstGeom prst="rect"/>
@@ -23315,7 +23315,7 @@
         </p:nvSpPr>
         <p:spPr>
           <a:xfrm rot="0" flipH="0" flipV="0">
-            <a:off x="1000125" y="3095625"/>
+            <a:off x="1000125" y="3496275"/>
             <a:ext cx="5505450" cy="238125"/>
           </a:xfrm>
           <a:prstGeom prst="rect"/>
@@ -23350,7 +23350,7 @@
         </p:nvSpPr>
         <p:spPr>
           <a:xfrm rot="0" flipH="0" flipV="0">
-            <a:off x="800100" y="3571875"/>
+            <a:off x="800100" y="3972525"/>
             <a:ext cx="5905500" cy="257175"/>
           </a:xfrm>
           <a:custGeom>
@@ -23390,7 +23390,7 @@
         </p:nvSpPr>
         <p:spPr>
           <a:xfrm rot="0" flipH="0" flipV="0">
-            <a:off x="971550" y="3571875"/>
+            <a:off x="971550" y="3972525"/>
             <a:ext cx="5695950" cy="257175"/>
           </a:xfrm>
           <a:prstGeom prst="rect"/>
@@ -23435,7 +23435,7 @@
         </p:nvSpPr>
         <p:spPr>
           <a:xfrm rot="0" flipH="0" flipV="0">
-            <a:off x="6915150" y="1085850"/>
+            <a:off x="6915150" y="1486500"/>
             <a:ext cx="4476750" cy="4191000"/>
           </a:xfrm>
           <a:prstGeom prst="roundRect">
@@ -23461,7 +23461,7 @@
         </p:nvSpPr>
         <p:spPr>
           <a:xfrm rot="0" flipH="0" flipV="0">
-            <a:off x="7124700" y="1257300"/>
+            <a:off x="7124700" y="1657950"/>
             <a:ext cx="4057650" cy="161925"/>
           </a:xfrm>
           <a:prstGeom prst="rect"/>
@@ -23496,7 +23496,7 @@
         </p:nvSpPr>
         <p:spPr>
           <a:xfrm rot="0" flipH="0" flipV="0">
-            <a:off x="7124700" y="1495425"/>
+            <a:off x="7124700" y="1896075"/>
             <a:ext cx="4057650" cy="3781425"/>
           </a:xfrm>
           <a:prstGeom prst="rect"/>
@@ -23896,7 +23896,7 @@
         </p:nvSpPr>
         <p:spPr>
           <a:xfrm rot="0" flipH="0" flipV="0">
-            <a:off x="800100" y="1085850"/>
+            <a:off x="800100" y="1453162"/>
             <a:ext cx="4476750" cy="2733675"/>
           </a:xfrm>
           <a:prstGeom prst="roundRect">
@@ -23922,7 +23922,7 @@
         </p:nvSpPr>
         <p:spPr>
           <a:xfrm rot="0" flipH="0" flipV="0">
-            <a:off x="1009650" y="1238250"/>
+            <a:off x="1009650" y="1605562"/>
             <a:ext cx="4057650" cy="161925"/>
           </a:xfrm>
           <a:prstGeom prst="rect"/>
@@ -23957,7 +23957,7 @@
         </p:nvSpPr>
         <p:spPr>
           <a:xfrm rot="0" flipH="0" flipV="0">
-            <a:off x="1009650" y="1457325"/>
+            <a:off x="1009650" y="1824637"/>
             <a:ext cx="4057650" cy="2209800"/>
           </a:xfrm>
           <a:prstGeom prst="rect"/>
@@ -24085,7 +24085,7 @@
         </p:nvSpPr>
         <p:spPr>
           <a:xfrm rot="0" flipH="0" flipV="0">
-            <a:off x="800100" y="3933825"/>
+            <a:off x="800100" y="4301137"/>
             <a:ext cx="4476750" cy="762000"/>
           </a:xfrm>
           <a:prstGeom prst="roundRect">
@@ -24116,7 +24116,7 @@
         </p:nvSpPr>
         <p:spPr>
           <a:xfrm rot="0" flipH="0" flipV="0">
-            <a:off x="971550" y="4057650"/>
+            <a:off x="971550" y="4424962"/>
             <a:ext cx="4133850" cy="514350"/>
           </a:xfrm>
           <a:prstGeom prst="rect"/>
@@ -24163,7 +24163,7 @@
         </p:nvSpPr>
         <p:spPr>
           <a:xfrm rot="0" flipH="0" flipV="0">
-            <a:off x="5524500" y="1704975"/>
+            <a:off x="5524500" y="2072287"/>
             <a:ext cx="5867400" cy="200025"/>
           </a:xfrm>
           <a:prstGeom prst="rect"/>
@@ -24198,7 +24198,7 @@
         </p:nvSpPr>
         <p:spPr>
           <a:xfrm rot="0" flipH="0" flipV="0">
-            <a:off x="5562600" y="2009775"/>
+            <a:off x="5562600" y="2377087"/>
             <a:ext cx="5867400" cy="600075"/>
           </a:xfrm>
           <a:prstGeom prst="roundRect">
@@ -24224,7 +24224,7 @@
         </p:nvSpPr>
         <p:spPr>
           <a:xfrm rot="0" flipH="0" flipV="0">
-            <a:off x="5562600" y="2009775"/>
+            <a:off x="5562600" y="2377087"/>
             <a:ext cx="5867400" cy="600075"/>
           </a:xfrm>
           <a:custGeom>
@@ -24281,7 +24281,7 @@
         </p:nvSpPr>
         <p:spPr>
           <a:xfrm rot="0" flipH="0" flipV="0">
-            <a:off x="5715000" y="2124075"/>
+            <a:off x="5715000" y="2491387"/>
             <a:ext cx="5524500" cy="180975"/>
           </a:xfrm>
           <a:prstGeom prst="rect"/>
@@ -24316,7 +24316,7 @@
         </p:nvSpPr>
         <p:spPr>
           <a:xfrm rot="0" flipH="0" flipV="0">
-            <a:off x="5715000" y="2352675"/>
+            <a:off x="5715000" y="2719987"/>
             <a:ext cx="5524500" cy="142875"/>
           </a:xfrm>
           <a:prstGeom prst="rect"/>
@@ -24361,7 +24361,7 @@
         </p:nvSpPr>
         <p:spPr>
           <a:xfrm rot="0" flipH="0" flipV="0">
-            <a:off x="5562600" y="2714625"/>
+            <a:off x="5562600" y="3081937"/>
             <a:ext cx="5867400" cy="600075"/>
           </a:xfrm>
           <a:prstGeom prst="roundRect">
@@ -24387,7 +24387,7 @@
         </p:nvSpPr>
         <p:spPr>
           <a:xfrm rot="0" flipH="0" flipV="0">
-            <a:off x="5562600" y="2714625"/>
+            <a:off x="5562600" y="3081937"/>
             <a:ext cx="5867400" cy="600075"/>
           </a:xfrm>
           <a:custGeom>
@@ -24444,7 +24444,7 @@
         </p:nvSpPr>
         <p:spPr>
           <a:xfrm rot="0" flipH="0" flipV="0">
-            <a:off x="5715000" y="2828925"/>
+            <a:off x="5715000" y="3196237"/>
             <a:ext cx="5524500" cy="180975"/>
           </a:xfrm>
           <a:prstGeom prst="rect"/>
@@ -24479,7 +24479,7 @@
         </p:nvSpPr>
         <p:spPr>
           <a:xfrm rot="0" flipH="0" flipV="0">
-            <a:off x="5715000" y="3057525"/>
+            <a:off x="5715000" y="3424837"/>
             <a:ext cx="5524500" cy="142875"/>
           </a:xfrm>
           <a:prstGeom prst="rect"/>
@@ -24524,7 +24524,7 @@
         </p:nvSpPr>
         <p:spPr>
           <a:xfrm rot="0" flipH="0" flipV="0">
-            <a:off x="5562600" y="3419475"/>
+            <a:off x="5562600" y="3786787"/>
             <a:ext cx="5867400" cy="600075"/>
           </a:xfrm>
           <a:prstGeom prst="roundRect">
@@ -24550,7 +24550,7 @@
         </p:nvSpPr>
         <p:spPr>
           <a:xfrm rot="0" flipH="0" flipV="0">
-            <a:off x="5562600" y="3419475"/>
+            <a:off x="5562600" y="3786787"/>
             <a:ext cx="5867400" cy="600075"/>
           </a:xfrm>
           <a:custGeom>
@@ -24607,7 +24607,7 @@
         </p:nvSpPr>
         <p:spPr>
           <a:xfrm rot="0" flipH="0" flipV="0">
-            <a:off x="5715000" y="3533775"/>
+            <a:off x="5715000" y="3901087"/>
             <a:ext cx="5524500" cy="180975"/>
           </a:xfrm>
           <a:prstGeom prst="rect"/>
@@ -24642,7 +24642,7 @@
         </p:nvSpPr>
         <p:spPr>
           <a:xfrm rot="0" flipH="0" flipV="0">
-            <a:off x="5715000" y="3762375"/>
+            <a:off x="5715000" y="4129687"/>
             <a:ext cx="5524500" cy="142875"/>
           </a:xfrm>
           <a:prstGeom prst="rect"/>
@@ -24687,7 +24687,7 @@
         </p:nvSpPr>
         <p:spPr>
           <a:xfrm rot="0" flipH="0" flipV="0">
-            <a:off x="5562600" y="4124325"/>
+            <a:off x="5562600" y="4491637"/>
             <a:ext cx="5867400" cy="600075"/>
           </a:xfrm>
           <a:prstGeom prst="roundRect">
@@ -24713,7 +24713,7 @@
         </p:nvSpPr>
         <p:spPr>
           <a:xfrm rot="0" flipH="0" flipV="0">
-            <a:off x="5562600" y="4124325"/>
+            <a:off x="5562600" y="4491637"/>
             <a:ext cx="5867400" cy="600075"/>
           </a:xfrm>
           <a:custGeom>
@@ -24770,7 +24770,7 @@
         </p:nvSpPr>
         <p:spPr>
           <a:xfrm rot="0" flipH="0" flipV="0">
-            <a:off x="5715000" y="4238625"/>
+            <a:off x="5715000" y="4605937"/>
             <a:ext cx="5524500" cy="180975"/>
           </a:xfrm>
           <a:prstGeom prst="rect"/>
@@ -24805,7 +24805,7 @@
         </p:nvSpPr>
         <p:spPr>
           <a:xfrm rot="0" flipH="0" flipV="0">
-            <a:off x="5715000" y="4467225"/>
+            <a:off x="5715000" y="4834537"/>
             <a:ext cx="5524500" cy="142875"/>
           </a:xfrm>
           <a:prstGeom prst="rect"/>
@@ -24850,7 +24850,7 @@
         </p:nvSpPr>
         <p:spPr>
           <a:xfrm rot="0" flipH="0" flipV="0">
-            <a:off x="5524500" y="4829175"/>
+            <a:off x="5524500" y="5196487"/>
             <a:ext cx="5905500" cy="514350"/>
           </a:xfrm>
           <a:custGeom>
@@ -24890,7 +24890,7 @@
         </p:nvSpPr>
         <p:spPr>
           <a:xfrm rot="0" flipH="0" flipV="0">
-            <a:off x="5695950" y="4829175"/>
+            <a:off x="5695950" y="5196487"/>
             <a:ext cx="5695950" cy="514350"/>
           </a:xfrm>
           <a:prstGeom prst="rect"/>
@@ -25160,7 +25160,7 @@
         <p:spPr>
           <a:xfrm rot="0" flipH="0" flipV="0">
             <a:off x="800100" y="1123950"/>
-            <a:ext cx="3419475" cy="3981450"/>
+            <a:ext cx="3419475" cy="3520199"/>
           </a:xfrm>
           <a:prstGeom prst="roundRect">
             <a:avLst>
@@ -25186,7 +25186,7 @@
         <p:spPr>
           <a:xfrm rot="0" flipH="0" flipV="0">
             <a:off x="800100" y="1123950"/>
-            <a:ext cx="3419475" cy="3981450"/>
+            <a:ext cx="3419475" cy="3520199"/>
           </a:xfrm>
           <a:custGeom>
             <a:pathLst>
@@ -25346,7 +25346,7 @@
         </p:blipFill>
         <p:spPr>
           <a:xfrm rot="0" flipH="0" flipV="0">
-            <a:off x="1419225" y="2505075"/>
+            <a:off x="1419225" y="2044800"/>
             <a:ext cx="2190750" cy="914400"/>
           </a:xfrm>
           <a:prstGeom prst="rect">
@@ -25363,7 +25363,7 @@
         </p:nvSpPr>
         <p:spPr>
           <a:xfrm rot="0" flipH="0" flipV="0">
-            <a:off x="962025" y="4286250"/>
+            <a:off x="962025" y="3825974"/>
             <a:ext cx="3095625" cy="142875"/>
           </a:xfrm>
           <a:prstGeom prst="rect"/>
@@ -25398,7 +25398,7 @@
         </p:nvSpPr>
         <p:spPr>
           <a:xfrm rot="0" flipH="0" flipV="0">
-            <a:off x="962025" y="4476750"/>
+            <a:off x="962025" y="4016475"/>
             <a:ext cx="3095625" cy="447675"/>
           </a:xfrm>
           <a:prstGeom prst="rect"/>
@@ -25446,7 +25446,7 @@
         <p:spPr>
           <a:xfrm rot="0" flipH="0" flipV="0">
             <a:off x="4391025" y="1123950"/>
-            <a:ext cx="3409950" cy="3981450"/>
+            <a:ext cx="3409950" cy="3520199"/>
           </a:xfrm>
           <a:prstGeom prst="roundRect">
             <a:avLst>
@@ -25472,7 +25472,7 @@
         <p:spPr>
           <a:xfrm rot="0" flipH="0" flipV="0">
             <a:off x="4391025" y="1123950"/>
-            <a:ext cx="3409950" cy="3981450"/>
+            <a:ext cx="3409950" cy="3520199"/>
           </a:xfrm>
           <a:custGeom>
             <a:pathLst>
@@ -25634,7 +25634,7 @@
         </p:blipFill>
         <p:spPr>
           <a:xfrm rot="0" flipH="0" flipV="0">
-            <a:off x="5000625" y="2533650"/>
+            <a:off x="5000625" y="2073375"/>
             <a:ext cx="2190750" cy="914400"/>
           </a:xfrm>
           <a:prstGeom prst="rect">
@@ -25651,7 +25651,7 @@
         </p:nvSpPr>
         <p:spPr>
           <a:xfrm rot="0" flipH="0" flipV="0">
-            <a:off x="4552950" y="4143375"/>
+            <a:off x="4552950" y="3683100"/>
             <a:ext cx="3086100" cy="285750"/>
           </a:xfrm>
           <a:prstGeom prst="rect"/>
@@ -25688,7 +25688,7 @@
         </p:nvSpPr>
         <p:spPr>
           <a:xfrm rot="0" flipH="0" flipV="0">
-            <a:off x="4552950" y="4476750"/>
+            <a:off x="4552950" y="4016475"/>
             <a:ext cx="3086100" cy="447675"/>
           </a:xfrm>
           <a:prstGeom prst="rect"/>
@@ -25736,7 +25736,7 @@
         <p:spPr>
           <a:xfrm rot="0" flipH="0" flipV="0">
             <a:off x="7972425" y="1123950"/>
-            <a:ext cx="3419475" cy="3981450"/>
+            <a:ext cx="3419475" cy="3520199"/>
           </a:xfrm>
           <a:prstGeom prst="roundRect">
             <a:avLst>
@@ -25762,7 +25762,7 @@
         <p:spPr>
           <a:xfrm rot="0" flipH="0" flipV="0">
             <a:off x="7972425" y="1123950"/>
-            <a:ext cx="3419475" cy="3981450"/>
+            <a:ext cx="3419475" cy="3520199"/>
           </a:xfrm>
           <a:custGeom>
             <a:pathLst>
@@ -25922,7 +25922,7 @@
         </p:blipFill>
         <p:spPr>
           <a:xfrm rot="0" flipH="0" flipV="0">
-            <a:off x="8591550" y="2505075"/>
+            <a:off x="8591550" y="2044800"/>
             <a:ext cx="2190750" cy="914400"/>
           </a:xfrm>
           <a:prstGeom prst="rect">
@@ -25939,7 +25939,7 @@
         </p:nvSpPr>
         <p:spPr>
           <a:xfrm rot="0" flipH="0" flipV="0">
-            <a:off x="8134350" y="4286250"/>
+            <a:off x="8134350" y="3825974"/>
             <a:ext cx="3095625" cy="142875"/>
           </a:xfrm>
           <a:prstGeom prst="rect"/>
@@ -25974,7 +25974,7 @@
         </p:nvSpPr>
         <p:spPr>
           <a:xfrm rot="0" flipH="0" flipV="0">
-            <a:off x="8134350" y="4476750"/>
+            <a:off x="8134350" y="4016475"/>
             <a:ext cx="3095625" cy="447675"/>
           </a:xfrm>
           <a:prstGeom prst="rect"/>
@@ -26021,7 +26021,7 @@
         </p:nvSpPr>
         <p:spPr>
           <a:xfrm rot="0" flipH="0" flipV="0">
-            <a:off x="800100" y="5200650"/>
+            <a:off x="800100" y="4739399"/>
             <a:ext cx="6438900" cy="762000"/>
           </a:xfrm>
           <a:prstGeom prst="roundRect">
@@ -26052,7 +26052,7 @@
         </p:nvSpPr>
         <p:spPr>
           <a:xfrm rot="0" flipH="0" flipV="0">
-            <a:off x="990600" y="5314950"/>
+            <a:off x="990600" y="4853699"/>
             <a:ext cx="6057900" cy="533400"/>
           </a:xfrm>
           <a:prstGeom prst="rect"/>
@@ -26129,7 +26129,7 @@
         </p:nvSpPr>
         <p:spPr>
           <a:xfrm rot="0" flipH="0" flipV="0">
-            <a:off x="7391400" y="5200650"/>
+            <a:off x="7391400" y="4739399"/>
             <a:ext cx="4000500" cy="762000"/>
           </a:xfrm>
           <a:custGeom>
@@ -26169,7 +26169,7 @@
         </p:nvSpPr>
         <p:spPr>
           <a:xfrm rot="0" flipH="0" flipV="0">
-            <a:off x="7562850" y="5314950"/>
+            <a:off x="7562850" y="4853699"/>
             <a:ext cx="3829050" cy="533400"/>
           </a:xfrm>
           <a:prstGeom prst="rect"/>
@@ -33624,7 +33624,7 @@
         </p:nvSpPr>
         <p:spPr>
           <a:xfrm rot="0" flipH="0" flipV="0">
-            <a:off x="800100" y="1104900"/>
+            <a:off x="800100" y="1681762"/>
             <a:ext cx="5753100" cy="209550"/>
           </a:xfrm>
           <a:prstGeom prst="rect"/>
@@ -33659,7 +33659,7 @@
         </p:nvSpPr>
         <p:spPr>
           <a:xfrm rot="0" flipH="0" flipV="0">
-            <a:off x="800100" y="1428750"/>
+            <a:off x="800100" y="2005612"/>
             <a:ext cx="5753100" cy="571500"/>
           </a:xfrm>
           <a:prstGeom prst="roundRect">
@@ -33704,7 +33704,7 @@
         </p:blipFill>
         <p:spPr>
           <a:xfrm rot="0" flipH="0" flipV="0">
-            <a:off x="952500" y="1552575"/>
+            <a:off x="952500" y="2129437"/>
             <a:ext cx="190500" cy="190500"/>
           </a:xfrm>
           <a:prstGeom prst="rect">
@@ -33721,7 +33721,7 @@
         </p:nvSpPr>
         <p:spPr>
           <a:xfrm rot="0" flipH="0" flipV="0">
-            <a:off x="1257300" y="1533525"/>
+            <a:off x="1257300" y="2110387"/>
             <a:ext cx="5143500" cy="190500"/>
           </a:xfrm>
           <a:prstGeom prst="rect"/>
@@ -33756,7 +33756,7 @@
         </p:nvSpPr>
         <p:spPr>
           <a:xfrm rot="0" flipH="0" flipV="0">
-            <a:off x="1257300" y="1733550"/>
+            <a:off x="1257300" y="2310412"/>
             <a:ext cx="5143500" cy="161925"/>
           </a:xfrm>
           <a:prstGeom prst="rect"/>
@@ -33791,7 +33791,7 @@
         </p:nvSpPr>
         <p:spPr>
           <a:xfrm rot="0" flipH="0" flipV="0">
-            <a:off x="800100" y="2114550"/>
+            <a:off x="800100" y="2691412"/>
             <a:ext cx="5753100" cy="571500"/>
           </a:xfrm>
           <a:prstGeom prst="roundRect">
@@ -33836,7 +33836,7 @@
         </p:blipFill>
         <p:spPr>
           <a:xfrm rot="0" flipH="0" flipV="0">
-            <a:off x="952500" y="2238375"/>
+            <a:off x="952500" y="2815237"/>
             <a:ext cx="190500" cy="190500"/>
           </a:xfrm>
           <a:prstGeom prst="rect">
@@ -33853,7 +33853,7 @@
         </p:nvSpPr>
         <p:spPr>
           <a:xfrm rot="0" flipH="0" flipV="0">
-            <a:off x="1257300" y="2219325"/>
+            <a:off x="1257300" y="2796187"/>
             <a:ext cx="5143500" cy="190500"/>
           </a:xfrm>
           <a:prstGeom prst="rect"/>
@@ -33888,7 +33888,7 @@
         </p:nvSpPr>
         <p:spPr>
           <a:xfrm rot="0" flipH="0" flipV="0">
-            <a:off x="1257300" y="2419350"/>
+            <a:off x="1257300" y="2996212"/>
             <a:ext cx="5143500" cy="161925"/>
           </a:xfrm>
           <a:prstGeom prst="rect"/>
@@ -33923,7 +33923,7 @@
         </p:nvSpPr>
         <p:spPr>
           <a:xfrm rot="0" flipH="0" flipV="0">
-            <a:off x="800100" y="2800350"/>
+            <a:off x="800100" y="3377212"/>
             <a:ext cx="5753100" cy="571500"/>
           </a:xfrm>
           <a:prstGeom prst="roundRect">
@@ -33968,7 +33968,7 @@
         </p:blipFill>
         <p:spPr>
           <a:xfrm rot="0" flipH="0" flipV="0">
-            <a:off x="952500" y="2924175"/>
+            <a:off x="952500" y="3501037"/>
             <a:ext cx="190500" cy="190500"/>
           </a:xfrm>
           <a:prstGeom prst="rect">
@@ -33985,7 +33985,7 @@
         </p:nvSpPr>
         <p:spPr>
           <a:xfrm rot="0" flipH="0" flipV="0">
-            <a:off x="1257300" y="2905125"/>
+            <a:off x="1257300" y="3481987"/>
             <a:ext cx="5143500" cy="190500"/>
           </a:xfrm>
           <a:prstGeom prst="rect"/>
@@ -34020,7 +34020,7 @@
         </p:nvSpPr>
         <p:spPr>
           <a:xfrm rot="0" flipH="0" flipV="0">
-            <a:off x="1257300" y="3105150"/>
+            <a:off x="1257300" y="3682012"/>
             <a:ext cx="5143500" cy="161925"/>
           </a:xfrm>
           <a:prstGeom prst="rect"/>
@@ -34055,7 +34055,7 @@
         </p:nvSpPr>
         <p:spPr>
           <a:xfrm rot="0" flipH="0" flipV="0">
-            <a:off x="800100" y="3486150"/>
+            <a:off x="800100" y="4063012"/>
             <a:ext cx="5753100" cy="571500"/>
           </a:xfrm>
           <a:prstGeom prst="roundRect">
@@ -34100,7 +34100,7 @@
         </p:blipFill>
         <p:spPr>
           <a:xfrm rot="0" flipH="0" flipV="0">
-            <a:off x="952500" y="3609975"/>
+            <a:off x="952500" y="4186837"/>
             <a:ext cx="190500" cy="190500"/>
           </a:xfrm>
           <a:prstGeom prst="rect">
@@ -34117,7 +34117,7 @@
         </p:nvSpPr>
         <p:spPr>
           <a:xfrm rot="0" flipH="0" flipV="0">
-            <a:off x="1257300" y="3590925"/>
+            <a:off x="1257300" y="4167787"/>
             <a:ext cx="5143500" cy="190500"/>
           </a:xfrm>
           <a:prstGeom prst="rect"/>
@@ -34152,7 +34152,7 @@
         </p:nvSpPr>
         <p:spPr>
           <a:xfrm rot="0" flipH="0" flipV="0">
-            <a:off x="1257300" y="3790950"/>
+            <a:off x="1257300" y="4367812"/>
             <a:ext cx="5143500" cy="161925"/>
           </a:xfrm>
           <a:prstGeom prst="rect"/>
@@ -34187,7 +34187,7 @@
         </p:nvSpPr>
         <p:spPr>
           <a:xfrm rot="0" flipH="0" flipV="0">
-            <a:off x="800100" y="4171950"/>
+            <a:off x="800100" y="4748812"/>
             <a:ext cx="5753100" cy="571500"/>
           </a:xfrm>
           <a:prstGeom prst="roundRect">
@@ -34232,7 +34232,7 @@
         </p:blipFill>
         <p:spPr>
           <a:xfrm rot="0" flipH="0" flipV="0">
-            <a:off x="952500" y="4295775"/>
+            <a:off x="952500" y="4872637"/>
             <a:ext cx="190500" cy="190500"/>
           </a:xfrm>
           <a:prstGeom prst="rect">
@@ -34249,7 +34249,7 @@
         </p:nvSpPr>
         <p:spPr>
           <a:xfrm rot="0" flipH="0" flipV="0">
-            <a:off x="1257300" y="4276725"/>
+            <a:off x="1257300" y="4853587"/>
             <a:ext cx="5143500" cy="190500"/>
           </a:xfrm>
           <a:prstGeom prst="rect"/>
@@ -34284,7 +34284,7 @@
         </p:nvSpPr>
         <p:spPr>
           <a:xfrm rot="0" flipH="0" flipV="0">
-            <a:off x="1257300" y="4476750"/>
+            <a:off x="1257300" y="5053612"/>
             <a:ext cx="5143500" cy="161925"/>
           </a:xfrm>
           <a:prstGeom prst="rect"/>
@@ -34319,7 +34319,7 @@
         </p:nvSpPr>
         <p:spPr>
           <a:xfrm rot="0" flipH="0" flipV="0">
-            <a:off x="6819900" y="1104900"/>
+            <a:off x="6819900" y="1681762"/>
             <a:ext cx="4572000" cy="209550"/>
           </a:xfrm>
           <a:prstGeom prst="rect"/>
@@ -34354,7 +34354,7 @@
         </p:nvSpPr>
         <p:spPr>
           <a:xfrm rot="0" flipH="0" flipV="0">
-            <a:off x="6819900" y="1447800"/>
+            <a:off x="6819900" y="2024662"/>
             <a:ext cx="4572000" cy="1809750"/>
           </a:xfrm>
           <a:prstGeom prst="roundRect">
@@ -34385,7 +34385,7 @@
         </p:nvSpPr>
         <p:spPr>
           <a:xfrm rot="0" flipH="0" flipV="0">
-            <a:off x="7029450" y="1638300"/>
+            <a:off x="7029450" y="2215162"/>
             <a:ext cx="419100" cy="285750"/>
           </a:xfrm>
           <a:prstGeom prst="roundRect">
@@ -34411,7 +34411,7 @@
         </p:nvSpPr>
         <p:spPr>
           <a:xfrm rot="0" flipH="0" flipV="0">
-            <a:off x="7143750" y="1704975"/>
+            <a:off x="7143750" y="2281837"/>
             <a:ext cx="200025" cy="161925"/>
           </a:xfrm>
           <a:prstGeom prst="rect"/>
@@ -34446,7 +34446,7 @@
         </p:nvSpPr>
         <p:spPr>
           <a:xfrm rot="0" flipH="0" flipV="0">
-            <a:off x="7562850" y="1695450"/>
+            <a:off x="7562850" y="2272312"/>
             <a:ext cx="1247775" cy="171450"/>
           </a:xfrm>
           <a:prstGeom prst="rect"/>
@@ -34495,7 +34495,7 @@
         </p:blipFill>
         <p:spPr>
           <a:xfrm rot="0" flipH="0" flipV="0">
-            <a:off x="8924925" y="1714500"/>
+            <a:off x="8924925" y="2291362"/>
             <a:ext cx="142875" cy="142875"/>
           </a:xfrm>
           <a:prstGeom prst="rect">
@@ -34512,7 +34512,7 @@
         </p:nvSpPr>
         <p:spPr>
           <a:xfrm rot="0" flipH="0" flipV="0">
-            <a:off x="7029450" y="2019300"/>
+            <a:off x="7029450" y="2596162"/>
             <a:ext cx="419100" cy="285750"/>
           </a:xfrm>
           <a:prstGeom prst="roundRect">
@@ -34538,7 +34538,7 @@
         </p:nvSpPr>
         <p:spPr>
           <a:xfrm rot="0" flipH="0" flipV="0">
-            <a:off x="7143750" y="2085975"/>
+            <a:off x="7143750" y="2662837"/>
             <a:ext cx="200025" cy="161925"/>
           </a:xfrm>
           <a:prstGeom prst="rect"/>
@@ -34573,7 +34573,7 @@
         </p:nvSpPr>
         <p:spPr>
           <a:xfrm rot="0" flipH="0" flipV="0">
-            <a:off x="7562850" y="2076450"/>
+            <a:off x="7562850" y="2653312"/>
             <a:ext cx="1466850" cy="171450"/>
           </a:xfrm>
           <a:prstGeom prst="rect"/>
@@ -34608,7 +34608,7 @@
         </p:nvSpPr>
         <p:spPr>
           <a:xfrm rot="0" flipH="0" flipV="0">
-            <a:off x="9144000" y="2076450"/>
+            <a:off x="9144000" y="2653312"/>
             <a:ext cx="476250" cy="180975"/>
           </a:xfrm>
           <a:prstGeom prst="roundRect">
@@ -34634,7 +34634,7 @@
         </p:nvSpPr>
         <p:spPr>
           <a:xfrm rot="0" flipH="0" flipV="0">
-            <a:off x="9239250" y="2095500"/>
+            <a:off x="9239250" y="2672362"/>
             <a:ext cx="285750" cy="142875"/>
           </a:xfrm>
           <a:prstGeom prst="rect"/>
@@ -34669,7 +34669,7 @@
         </p:nvSpPr>
         <p:spPr>
           <a:xfrm rot="0" flipH="0" flipV="0">
-            <a:off x="7029450" y="2400300"/>
+            <a:off x="7029450" y="2977162"/>
             <a:ext cx="419100" cy="285750"/>
           </a:xfrm>
           <a:prstGeom prst="roundRect">
@@ -34695,7 +34695,7 @@
         </p:nvSpPr>
         <p:spPr>
           <a:xfrm rot="0" flipH="0" flipV="0">
-            <a:off x="7143750" y="2466975"/>
+            <a:off x="7143750" y="3043837"/>
             <a:ext cx="200025" cy="161925"/>
           </a:xfrm>
           <a:prstGeom prst="rect"/>
@@ -34730,7 +34730,7 @@
         </p:nvSpPr>
         <p:spPr>
           <a:xfrm rot="0" flipH="0" flipV="0">
-            <a:off x="7562850" y="2457450"/>
+            <a:off x="7562850" y="3034312"/>
             <a:ext cx="2105025" cy="171450"/>
           </a:xfrm>
           <a:prstGeom prst="rect"/>
@@ -34765,7 +34765,7 @@
         </p:nvSpPr>
         <p:spPr>
           <a:xfrm rot="0" flipH="0" flipV="0">
-            <a:off x="7029450" y="2781300"/>
+            <a:off x="7029450" y="3358162"/>
             <a:ext cx="419100" cy="285750"/>
           </a:xfrm>
           <a:prstGeom prst="roundRect">
@@ -34791,7 +34791,7 @@
         </p:nvSpPr>
         <p:spPr>
           <a:xfrm rot="0" flipH="0" flipV="0">
-            <a:off x="7143750" y="2847975"/>
+            <a:off x="7143750" y="3424837"/>
             <a:ext cx="200025" cy="161925"/>
           </a:xfrm>
           <a:prstGeom prst="rect"/>
@@ -34826,7 +34826,7 @@
         </p:nvSpPr>
         <p:spPr>
           <a:xfrm rot="0" flipH="0" flipV="0">
-            <a:off x="7562850" y="2838450"/>
+            <a:off x="7562850" y="3415312"/>
             <a:ext cx="1647825" cy="171450"/>
           </a:xfrm>
           <a:prstGeom prst="rect"/>
@@ -34861,7 +34861,7 @@
         </p:nvSpPr>
         <p:spPr>
           <a:xfrm rot="0" flipH="0" flipV="0">
-            <a:off x="6819900" y="3390900"/>
+            <a:off x="6819900" y="3967762"/>
             <a:ext cx="4572000" cy="1514475"/>
           </a:xfrm>
           <a:prstGeom prst="roundRect">
@@ -34887,7 +34887,7 @@
         </p:nvSpPr>
         <p:spPr>
           <a:xfrm rot="0" flipH="0" flipV="0">
-            <a:off x="7029450" y="3562350"/>
+            <a:off x="7029450" y="4139212"/>
             <a:ext cx="4152900" cy="200025"/>
           </a:xfrm>
           <a:prstGeom prst="rect"/>
@@ -34922,7 +34922,7 @@
         </p:nvSpPr>
         <p:spPr>
           <a:xfrm rot="0" flipH="0" flipV="0">
-            <a:off x="7029450" y="3857625"/>
+            <a:off x="7029450" y="4434487"/>
             <a:ext cx="228600" cy="228600"/>
           </a:xfrm>
           <a:prstGeom prst="roundRect">
@@ -34950,7 +34950,7 @@
         </p:nvSpPr>
         <p:spPr>
           <a:xfrm rot="0" flipH="0" flipV="0">
-            <a:off x="7105650" y="3895725"/>
+            <a:off x="7105650" y="4472587"/>
             <a:ext cx="76200" cy="152400"/>
           </a:xfrm>
           <a:prstGeom prst="rect"/>
@@ -34985,7 +34985,7 @@
         </p:nvSpPr>
         <p:spPr>
           <a:xfrm rot="0" flipH="0" flipV="0">
-            <a:off x="7353300" y="3886200"/>
+            <a:off x="7353300" y="4463062"/>
             <a:ext cx="2428875" cy="171450"/>
           </a:xfrm>
           <a:prstGeom prst="rect"/>
@@ -35022,7 +35022,7 @@
         </p:nvSpPr>
         <p:spPr>
           <a:xfrm rot="0" flipH="0" flipV="0">
-            <a:off x="7029450" y="4181475"/>
+            <a:off x="7029450" y="4758337"/>
             <a:ext cx="228600" cy="228600"/>
           </a:xfrm>
           <a:prstGeom prst="roundRect">
@@ -35050,7 +35050,7 @@
         </p:nvSpPr>
         <p:spPr>
           <a:xfrm rot="0" flipH="0" flipV="0">
-            <a:off x="7105650" y="4219575"/>
+            <a:off x="7105650" y="4796437"/>
             <a:ext cx="76200" cy="152400"/>
           </a:xfrm>
           <a:prstGeom prst="rect"/>
@@ -35085,7 +35085,7 @@
         </p:nvSpPr>
         <p:spPr>
           <a:xfrm rot="0" flipH="0" flipV="0">
-            <a:off x="7353300" y="4210050"/>
+            <a:off x="7353300" y="4786912"/>
             <a:ext cx="2209800" cy="171450"/>
           </a:xfrm>
           <a:prstGeom prst="rect"/>
@@ -35122,7 +35122,7 @@
         </p:nvSpPr>
         <p:spPr>
           <a:xfrm rot="0" flipH="0" flipV="0">
-            <a:off x="7029450" y="4505325"/>
+            <a:off x="7029450" y="5082187"/>
             <a:ext cx="228600" cy="228600"/>
           </a:xfrm>
           <a:prstGeom prst="roundRect">
@@ -35150,7 +35150,7 @@
         </p:nvSpPr>
         <p:spPr>
           <a:xfrm rot="0" flipH="0" flipV="0">
-            <a:off x="7105650" y="4543425"/>
+            <a:off x="7105650" y="5120287"/>
             <a:ext cx="76200" cy="152400"/>
           </a:xfrm>
           <a:prstGeom prst="rect"/>
@@ -35185,7 +35185,7 @@
         </p:nvSpPr>
         <p:spPr>
           <a:xfrm rot="0" flipH="0" flipV="0">
-            <a:off x="7353300" y="4533900"/>
+            <a:off x="7353300" y="5110762"/>
             <a:ext cx="2714625" cy="171450"/>
           </a:xfrm>
           <a:prstGeom prst="rect"/>
@@ -35703,7 +35703,7 @@
                 <a:latin typeface="Inter"/>
                 <a:ea typeface="Inter"/>
               </a:rPr>
-              <a:t>The AI data workflow:</a:t>
+              <a:t>The AI data workflow: </a:t>
             </a:r>
             <a:r>
               <a:rPr lang="en-US" sz="1125">
@@ -37079,8 +37079,8 @@
         </p:nvSpPr>
         <p:spPr>
           <a:xfrm rot="0" flipH="0" flipV="0">
-            <a:off x="800100" y="1123950"/>
-            <a:ext cx="3400425" cy="3648075"/>
+            <a:off x="800100" y="1917150"/>
+            <a:ext cx="3400425" cy="2139074"/>
           </a:xfrm>
           <a:prstGeom prst="roundRect">
             <a:avLst>
@@ -37105,8 +37105,8 @@
         </p:nvSpPr>
         <p:spPr>
           <a:xfrm rot="0" flipH="0" flipV="0">
-            <a:off x="800100" y="1123950"/>
-            <a:ext cx="3400425" cy="3648075"/>
+            <a:off x="800100" y="1917150"/>
+            <a:ext cx="3400425" cy="2139074"/>
           </a:xfrm>
           <a:custGeom>
             <a:pathLst>
@@ -37162,7 +37162,7 @@
         </p:nvSpPr>
         <p:spPr>
           <a:xfrm rot="0" flipH="0" flipV="0">
-            <a:off x="990600" y="1295400"/>
+            <a:off x="990600" y="2088600"/>
             <a:ext cx="381000" cy="381000"/>
           </a:xfrm>
           <a:prstGeom prst="roundRect">
@@ -37202,7 +37202,7 @@
         </p:blipFill>
         <p:spPr>
           <a:xfrm rot="0" flipH="0" flipV="0">
-            <a:off x="1085850" y="1390650"/>
+            <a:off x="1085850" y="2183850"/>
             <a:ext cx="190500" cy="190500"/>
           </a:xfrm>
           <a:prstGeom prst="rect">
@@ -37219,7 +37219,7 @@
         </p:nvSpPr>
         <p:spPr>
           <a:xfrm rot="0" flipH="0" flipV="0">
-            <a:off x="1485900" y="1304925"/>
+            <a:off x="1485900" y="2098125"/>
             <a:ext cx="1362075" cy="219075"/>
           </a:xfrm>
           <a:prstGeom prst="rect"/>
@@ -37254,7 +37254,7 @@
         </p:nvSpPr>
         <p:spPr>
           <a:xfrm rot="0" flipH="0" flipV="0">
-            <a:off x="1485900" y="1524000"/>
+            <a:off x="1485900" y="2317200"/>
             <a:ext cx="1362075" cy="152400"/>
           </a:xfrm>
           <a:prstGeom prst="rect"/>
@@ -37289,7 +37289,7 @@
         </p:nvSpPr>
         <p:spPr>
           <a:xfrm rot="0" flipH="0" flipV="0">
-            <a:off x="990600" y="1790700"/>
+            <a:off x="990600" y="2583900"/>
             <a:ext cx="3019425" cy="533400"/>
           </a:xfrm>
           <a:prstGeom prst="rect"/>
@@ -37326,7 +37326,7 @@
         </p:nvSpPr>
         <p:spPr>
           <a:xfrm rot="0" flipH="0" flipV="0">
-            <a:off x="990600" y="4019550"/>
+            <a:off x="990600" y="3333300"/>
             <a:ext cx="3019425" cy="542925"/>
           </a:xfrm>
           <a:prstGeom prst="roundRect">
@@ -37352,7 +37352,7 @@
         </p:nvSpPr>
         <p:spPr>
           <a:xfrm rot="0" flipH="0" flipV="0">
-            <a:off x="1123950" y="4114800"/>
+            <a:off x="1123950" y="3428549"/>
             <a:ext cx="2752725" cy="152400"/>
           </a:xfrm>
           <a:prstGeom prst="rect"/>
@@ -37387,7 +37387,7 @@
         </p:nvSpPr>
         <p:spPr>
           <a:xfrm rot="0" flipH="0" flipV="0">
-            <a:off x="1123950" y="4295775"/>
+            <a:off x="1123950" y="3609525"/>
             <a:ext cx="2752725" cy="171450"/>
           </a:xfrm>
           <a:prstGeom prst="rect"/>
@@ -37422,8 +37422,8 @@
         </p:nvSpPr>
         <p:spPr>
           <a:xfrm rot="0" flipH="0" flipV="0">
-            <a:off x="4391025" y="1123950"/>
-            <a:ext cx="3409950" cy="3648075"/>
+            <a:off x="4391025" y="1917150"/>
+            <a:ext cx="3409950" cy="2139074"/>
           </a:xfrm>
           <a:prstGeom prst="roundRect">
             <a:avLst>
@@ -37448,8 +37448,8 @@
         </p:nvSpPr>
         <p:spPr>
           <a:xfrm rot="0" flipH="0" flipV="0">
-            <a:off x="4391025" y="1123950"/>
-            <a:ext cx="3409950" cy="3648075"/>
+            <a:off x="4391025" y="1917150"/>
+            <a:ext cx="3409950" cy="2139074"/>
           </a:xfrm>
           <a:custGeom>
             <a:pathLst>
@@ -37505,7 +37505,7 @@
         </p:nvSpPr>
         <p:spPr>
           <a:xfrm rot="0" flipH="0" flipV="0">
-            <a:off x="4581525" y="1295400"/>
+            <a:off x="4581525" y="2088600"/>
             <a:ext cx="381000" cy="381000"/>
           </a:xfrm>
           <a:prstGeom prst="roundRect">
@@ -37545,7 +37545,7 @@
         </p:blipFill>
         <p:spPr>
           <a:xfrm rot="0" flipH="0" flipV="0">
-            <a:off x="4676775" y="1390650"/>
+            <a:off x="4676775" y="2183850"/>
             <a:ext cx="190500" cy="190500"/>
           </a:xfrm>
           <a:prstGeom prst="rect">
@@ -37562,7 +37562,7 @@
         </p:nvSpPr>
         <p:spPr>
           <a:xfrm rot="0" flipH="0" flipV="0">
-            <a:off x="5076825" y="1304925"/>
+            <a:off x="5076825" y="2098125"/>
             <a:ext cx="1838325" cy="219075"/>
           </a:xfrm>
           <a:prstGeom prst="rect"/>
@@ -37597,7 +37597,7 @@
         </p:nvSpPr>
         <p:spPr>
           <a:xfrm rot="0" flipH="0" flipV="0">
-            <a:off x="5076825" y="1524000"/>
+            <a:off x="5076825" y="2317200"/>
             <a:ext cx="1838325" cy="152400"/>
           </a:xfrm>
           <a:prstGeom prst="rect"/>
@@ -37632,7 +37632,7 @@
         </p:nvSpPr>
         <p:spPr>
           <a:xfrm rot="0" flipH="0" flipV="0">
-            <a:off x="4581525" y="1790700"/>
+            <a:off x="4581525" y="2583900"/>
             <a:ext cx="3028950" cy="533400"/>
           </a:xfrm>
           <a:prstGeom prst="rect"/>
@@ -37669,7 +37669,7 @@
         </p:nvSpPr>
         <p:spPr>
           <a:xfrm rot="0" flipH="0" flipV="0">
-            <a:off x="4581525" y="4019550"/>
+            <a:off x="4581525" y="3333300"/>
             <a:ext cx="3028950" cy="542925"/>
           </a:xfrm>
           <a:prstGeom prst="roundRect">
@@ -37695,7 +37695,7 @@
         </p:nvSpPr>
         <p:spPr>
           <a:xfrm rot="0" flipH="0" flipV="0">
-            <a:off x="4714875" y="4114800"/>
+            <a:off x="4714875" y="3428549"/>
             <a:ext cx="2762250" cy="152400"/>
           </a:xfrm>
           <a:prstGeom prst="rect"/>
@@ -37730,7 +37730,7 @@
         </p:nvSpPr>
         <p:spPr>
           <a:xfrm rot="0" flipH="0" flipV="0">
-            <a:off x="4714875" y="4295775"/>
+            <a:off x="4714875" y="3609525"/>
             <a:ext cx="2762250" cy="171450"/>
           </a:xfrm>
           <a:prstGeom prst="rect"/>
@@ -37765,8 +37765,8 @@
         </p:nvSpPr>
         <p:spPr>
           <a:xfrm rot="0" flipH="0" flipV="0">
-            <a:off x="7991475" y="1123950"/>
-            <a:ext cx="3400425" cy="3648075"/>
+            <a:off x="7991475" y="1917150"/>
+            <a:ext cx="3400425" cy="2139074"/>
           </a:xfrm>
           <a:prstGeom prst="roundRect">
             <a:avLst>
@@ -37791,8 +37791,8 @@
         </p:nvSpPr>
         <p:spPr>
           <a:xfrm rot="0" flipH="0" flipV="0">
-            <a:off x="7991475" y="1123950"/>
-            <a:ext cx="3400425" cy="3648075"/>
+            <a:off x="7991475" y="1917150"/>
+            <a:ext cx="3400425" cy="2139074"/>
           </a:xfrm>
           <a:custGeom>
             <a:pathLst>
@@ -37848,7 +37848,7 @@
         </p:nvSpPr>
         <p:spPr>
           <a:xfrm rot="0" flipH="0" flipV="0">
-            <a:off x="8181975" y="1295400"/>
+            <a:off x="8181975" y="2088600"/>
             <a:ext cx="381000" cy="381000"/>
           </a:xfrm>
           <a:prstGeom prst="roundRect">
@@ -37888,7 +37888,7 @@
         </p:blipFill>
         <p:spPr>
           <a:xfrm rot="0" flipH="0" flipV="0">
-            <a:off x="8277225" y="1390650"/>
+            <a:off x="8277225" y="2183850"/>
             <a:ext cx="190500" cy="190500"/>
           </a:xfrm>
           <a:prstGeom prst="rect">
@@ -37905,7 +37905,7 @@
         </p:nvSpPr>
         <p:spPr>
           <a:xfrm rot="0" flipH="0" flipV="0">
-            <a:off x="8677275" y="1304925"/>
+            <a:off x="8677275" y="2098125"/>
             <a:ext cx="1581150" cy="219075"/>
           </a:xfrm>
           <a:prstGeom prst="rect"/>
@@ -37940,7 +37940,7 @@
         </p:nvSpPr>
         <p:spPr>
           <a:xfrm rot="0" flipH="0" flipV="0">
-            <a:off x="8677275" y="1524000"/>
+            <a:off x="8677275" y="2317200"/>
             <a:ext cx="1581150" cy="152400"/>
           </a:xfrm>
           <a:prstGeom prst="rect"/>
@@ -37975,7 +37975,7 @@
         </p:nvSpPr>
         <p:spPr>
           <a:xfrm rot="0" flipH="0" flipV="0">
-            <a:off x="8181975" y="1790700"/>
+            <a:off x="8181975" y="2583900"/>
             <a:ext cx="3019425" cy="533400"/>
           </a:xfrm>
           <a:prstGeom prst="rect"/>
@@ -38012,7 +38012,7 @@
         </p:nvSpPr>
         <p:spPr>
           <a:xfrm rot="0" flipH="0" flipV="0">
-            <a:off x="8181975" y="4019550"/>
+            <a:off x="8181975" y="3333300"/>
             <a:ext cx="3019425" cy="542925"/>
           </a:xfrm>
           <a:prstGeom prst="roundRect">
@@ -38038,7 +38038,7 @@
         </p:nvSpPr>
         <p:spPr>
           <a:xfrm rot="0" flipH="0" flipV="0">
-            <a:off x="8315325" y="4114800"/>
+            <a:off x="8315325" y="3428549"/>
             <a:ext cx="2752725" cy="152400"/>
           </a:xfrm>
           <a:prstGeom prst="rect"/>
@@ -38073,7 +38073,7 @@
         </p:nvSpPr>
         <p:spPr>
           <a:xfrm rot="0" flipH="0" flipV="0">
-            <a:off x="8315325" y="4295775"/>
+            <a:off x="8315325" y="3609525"/>
             <a:ext cx="2752725" cy="171450"/>
           </a:xfrm>
           <a:prstGeom prst="rect"/>
@@ -38108,7 +38108,7 @@
         </p:nvSpPr>
         <p:spPr>
           <a:xfrm rot="0" flipH="0" flipV="0">
-            <a:off x="800100" y="4886325"/>
+            <a:off x="800100" y="4170525"/>
             <a:ext cx="5200650" cy="1076325"/>
           </a:xfrm>
           <a:prstGeom prst="roundRect">
@@ -38139,7 +38139,7 @@
         </p:nvSpPr>
         <p:spPr>
           <a:xfrm rot="0" flipH="0" flipV="0">
-            <a:off x="990600" y="5010150"/>
+            <a:off x="990600" y="4294350"/>
             <a:ext cx="4819650" cy="828675"/>
           </a:xfrm>
           <a:prstGeom prst="rect"/>
@@ -38162,7 +38162,7 @@
                 <a:latin typeface="Inter"/>
                 <a:ea typeface="Inter"/>
               </a:rPr>
-              <a:t>Where data comes from:</a:t>
+              <a:t>Where data comes from: </a:t>
             </a:r>
             <a:r>
               <a:rPr lang="en-US" sz="1125">
@@ -38186,7 +38186,7 @@
         </p:nvSpPr>
         <p:spPr>
           <a:xfrm rot="0" flipH="0" flipV="0">
-            <a:off x="6191250" y="4886325"/>
+            <a:off x="6191250" y="4170525"/>
             <a:ext cx="5238750" cy="1076325"/>
           </a:xfrm>
           <a:custGeom>
@@ -38226,7 +38226,7 @@
         </p:nvSpPr>
         <p:spPr>
           <a:xfrm rot="0" flipH="0" flipV="0">
-            <a:off x="6362700" y="5153025"/>
+            <a:off x="6362700" y="4437225"/>
             <a:ext cx="5029200" cy="552450"/>
           </a:xfrm>
           <a:prstGeom prst="rect"/>
@@ -38269,7 +38269,7 @@
                 <a:latin typeface="Inter"/>
                 <a:ea typeface="Inter"/>
               </a:rPr>
-              <a:t>Sources set the ceiling of quality.</a:t>
+              <a:t/>
             </a:r>
             <a:endParaRPr/>
           </a:p>

</xml_diff>